<commit_message>
Align the note with the 35/20/15/15/15 basket; cut to 10 content slides
Re-priced on the strategy-slide weights: fair coupon 11.1%, offer 10.25% (below the lowest
market-sensitivity fair coupon), Natixis margin 2.9%. Note deck: timeline and payoff merged,
building blocks moved to Appendix B, slides renumbered 1-8. Thesis/strategy file: duplicate
macro slide removed, leaving the one-page thesis and the strategy slide.

Co-Authored-By: Claude Opus 5.5 <noreply@anthropic.com>
Claude-Session: https://claude.ai/code/session_01Rwoh8cFDQqLD8JWT3mee6y
</commit_message>
<xml_diff>
--- a/final/Thesis-and-Strategy.pptx
+++ b/final/Thesis-and-Strategy.pptx
@@ -8,7 +8,6 @@
     <p:notesMasterId r:id="rId5"/>
   </p:notesMasterIdLst>
   <p:sldIdLst>
-    <p:sldId id="260" r:id="rId2"/>
     <p:sldId id="257" r:id="rId3"/>
     <p:sldId id="256" r:id="rId4"/>
   </p:sldIdLst>
@@ -112,1394 +111,6 @@
     </p:ext>
   </p:extLst>
 </p:presentation>
-</file>
-
-<file path=ppt/charts/chart1.xml><?xml version="1.0" encoding="utf-8"?>
-<c:chartSpace xmlns:c="http://schemas.openxmlformats.org/drawingml/2006/chart" xmlns:a="http://schemas.openxmlformats.org/drawingml/2006/main" xmlns:r="http://schemas.openxmlformats.org/officeDocument/2006/relationships" xmlns:c16r2="http://schemas.microsoft.com/office/drawing/2015/06/chart">
-  <c:date1904 val="0"/>
-  <c:lang val="en-US"/>
-  <c:roundedCorners val="1"/>
-  <c:style val="2"/>
-  <c:chart>
-    <c:autoTitleDeleted val="1"/>
-    <c:plotArea>
-      <c:layout/>
-      <c:lineChart>
-        <c:grouping val="standard"/>
-        <c:varyColors val="0"/>
-        <c:ser>
-          <c:idx val="0"/>
-          <c:order val="0"/>
-          <c:tx>
-            <c:strRef>
-              <c:f>Sheet1!$B$1</c:f>
-              <c:strCache>
-                <c:ptCount val="1"/>
-                <c:pt idx="0">
-                  <c:v>Fed funds (upper bound)</c:v>
-                </c:pt>
-              </c:strCache>
-            </c:strRef>
-          </c:tx>
-          <c:spPr>
-            <a:ln w="28575" cap="flat">
-              <a:solidFill>
-                <a:srgbClr val="2C5F82"/>
-              </a:solidFill>
-              <a:prstDash val="solid"/>
-              <a:round/>
-            </a:ln>
-            <a:effectLst/>
-          </c:spPr>
-          <c:marker>
-            <c:symbol val="none"/>
-          </c:marker>
-          <c:cat>
-            <c:strRef>
-              <c:f>Sheet1!$A$2:$A$20</c:f>
-              <c:strCache>
-                <c:ptCount val="19"/>
-                <c:pt idx="0">
-                  <c:v>Q1-22</c:v>
-                </c:pt>
-                <c:pt idx="1">
-                  <c:v>Q2-22</c:v>
-                </c:pt>
-                <c:pt idx="2">
-                  <c:v>Q3-22</c:v>
-                </c:pt>
-                <c:pt idx="3">
-                  <c:v>Q4-22</c:v>
-                </c:pt>
-                <c:pt idx="4">
-                  <c:v>Q1-23</c:v>
-                </c:pt>
-                <c:pt idx="5">
-                  <c:v>Q2-23</c:v>
-                </c:pt>
-                <c:pt idx="6">
-                  <c:v>Q3-23</c:v>
-                </c:pt>
-                <c:pt idx="7">
-                  <c:v>Q4-23</c:v>
-                </c:pt>
-                <c:pt idx="8">
-                  <c:v>Q1-24</c:v>
-                </c:pt>
-                <c:pt idx="9">
-                  <c:v>Q2-24</c:v>
-                </c:pt>
-                <c:pt idx="10">
-                  <c:v>Q3-24</c:v>
-                </c:pt>
-                <c:pt idx="11">
-                  <c:v>Q4-24</c:v>
-                </c:pt>
-                <c:pt idx="12">
-                  <c:v>Q1-25</c:v>
-                </c:pt>
-                <c:pt idx="13">
-                  <c:v>Q2-25</c:v>
-                </c:pt>
-                <c:pt idx="14">
-                  <c:v>Q3-25</c:v>
-                </c:pt>
-                <c:pt idx="15">
-                  <c:v>Q4-25</c:v>
-                </c:pt>
-                <c:pt idx="16">
-                  <c:v>Q1-26</c:v>
-                </c:pt>
-                <c:pt idx="17">
-                  <c:v>Q2-26</c:v>
-                </c:pt>
-                <c:pt idx="18">
-                  <c:v>Q3-26</c:v>
-                </c:pt>
-              </c:strCache>
-            </c:strRef>
-          </c:cat>
-          <c:val>
-            <c:numRef>
-              <c:f>Sheet1!$B$2:$B$20</c:f>
-              <c:numCache>
-                <c:formatCode>General</c:formatCode>
-                <c:ptCount val="19"/>
-                <c:pt idx="0">
-                  <c:v>0.5</c:v>
-                </c:pt>
-                <c:pt idx="1">
-                  <c:v>1.75</c:v>
-                </c:pt>
-                <c:pt idx="2">
-                  <c:v>3.25</c:v>
-                </c:pt>
-                <c:pt idx="3">
-                  <c:v>4.5</c:v>
-                </c:pt>
-                <c:pt idx="4">
-                  <c:v>5</c:v>
-                </c:pt>
-                <c:pt idx="5">
-                  <c:v>5.25</c:v>
-                </c:pt>
-                <c:pt idx="6">
-                  <c:v>5.5</c:v>
-                </c:pt>
-                <c:pt idx="7">
-                  <c:v>5.5</c:v>
-                </c:pt>
-                <c:pt idx="8">
-                  <c:v>5.5</c:v>
-                </c:pt>
-                <c:pt idx="9">
-                  <c:v>5.5</c:v>
-                </c:pt>
-                <c:pt idx="10">
-                  <c:v>5</c:v>
-                </c:pt>
-                <c:pt idx="11">
-                  <c:v>4.5</c:v>
-                </c:pt>
-                <c:pt idx="12">
-                  <c:v>4.5</c:v>
-                </c:pt>
-                <c:pt idx="13">
-                  <c:v>4.5</c:v>
-                </c:pt>
-                <c:pt idx="14">
-                  <c:v>4.25</c:v>
-                </c:pt>
-                <c:pt idx="15">
-                  <c:v>3.75</c:v>
-                </c:pt>
-                <c:pt idx="16">
-                  <c:v>3.75</c:v>
-                </c:pt>
-                <c:pt idx="17">
-                  <c:v>3.75</c:v>
-                </c:pt>
-                <c:pt idx="18">
-                  <c:v>4</c:v>
-                </c:pt>
-              </c:numCache>
-            </c:numRef>
-          </c:val>
-          <c:smooth val="0"/>
-          <c:extLst>
-            <c:ext xmlns:c16="http://schemas.microsoft.com/office/drawing/2014/chart" uri="{C3380CC4-5D6E-409C-BE32-E72D297353CC}">
-              <c16:uniqueId val="{00000000-3CB9-8A4E-BA6A-A7E1848476F9}"/>
-            </c:ext>
-          </c:extLst>
-        </c:ser>
-        <c:dLbls>
-          <c:showLegendKey val="0"/>
-          <c:showVal val="0"/>
-          <c:showCatName val="0"/>
-          <c:showSerName val="0"/>
-          <c:showPercent val="0"/>
-          <c:showBubbleSize val="0"/>
-        </c:dLbls>
-        <c:smooth val="0"/>
-        <c:axId val="2094734554"/>
-        <c:axId val="2094734552"/>
-      </c:lineChart>
-      <c:catAx>
-        <c:axId val="2094734554"/>
-        <c:scaling>
-          <c:orientation val="minMax"/>
-        </c:scaling>
-        <c:delete val="0"/>
-        <c:axPos val="b"/>
-        <c:numFmt formatCode="General" sourceLinked="1"/>
-        <c:majorTickMark val="out"/>
-        <c:minorTickMark val="none"/>
-        <c:tickLblPos val="low"/>
-        <c:spPr>
-          <a:ln w="12700" cap="flat">
-            <a:solidFill>
-              <a:srgbClr val="BFBFBF"/>
-            </a:solidFill>
-            <a:prstDash val="solid"/>
-            <a:round/>
-          </a:ln>
-        </c:spPr>
-        <c:txPr>
-          <a:bodyPr/>
-          <a:lstStyle/>
-          <a:p>
-            <a:pPr>
-              <a:defRPr sz="650" b="0" i="0" u="none" strike="noStrike">
-                <a:solidFill>
-                  <a:srgbClr val="595959"/>
-                </a:solidFill>
-                <a:latin typeface="Arial"/>
-              </a:defRPr>
-            </a:pPr>
-            <a:endParaRPr lang="en-US"/>
-          </a:p>
-        </c:txPr>
-        <c:crossAx val="2094734552"/>
-        <c:crosses val="autoZero"/>
-        <c:auto val="1"/>
-        <c:lblAlgn val="ctr"/>
-        <c:lblOffset val="100"/>
-        <c:noMultiLvlLbl val="1"/>
-      </c:catAx>
-      <c:valAx>
-        <c:axId val="2094734552"/>
-        <c:scaling>
-          <c:orientation val="minMax"/>
-          <c:max val="6"/>
-          <c:min val="0"/>
-        </c:scaling>
-        <c:delete val="0"/>
-        <c:axPos val="l"/>
-        <c:majorGridlines>
-          <c:spPr>
-            <a:ln w="6350" cap="flat">
-              <a:solidFill>
-                <a:srgbClr val="E3E3E3"/>
-              </a:solidFill>
-              <a:prstDash val="solid"/>
-              <a:round/>
-            </a:ln>
-          </c:spPr>
-        </c:majorGridlines>
-        <c:numFmt formatCode="0&quot;%&quot;" sourceLinked="0"/>
-        <c:majorTickMark val="out"/>
-        <c:minorTickMark val="none"/>
-        <c:tickLblPos val="nextTo"/>
-        <c:spPr>
-          <a:ln w="12700" cap="flat">
-            <a:solidFill>
-              <a:srgbClr val="888888"/>
-            </a:solidFill>
-            <a:prstDash val="solid"/>
-            <a:round/>
-          </a:ln>
-        </c:spPr>
-        <c:txPr>
-          <a:bodyPr/>
-          <a:lstStyle/>
-          <a:p>
-            <a:pPr>
-              <a:defRPr sz="800" b="0" i="0" u="none" strike="noStrike">
-                <a:solidFill>
-                  <a:srgbClr val="595959"/>
-                </a:solidFill>
-                <a:latin typeface="Arial"/>
-              </a:defRPr>
-            </a:pPr>
-            <a:endParaRPr lang="en-US"/>
-          </a:p>
-        </c:txPr>
-        <c:crossAx val="2094734554"/>
-        <c:crosses val="autoZero"/>
-        <c:crossBetween val="between"/>
-        <c:majorUnit val="2"/>
-      </c:valAx>
-      <c:spPr>
-        <a:noFill/>
-        <a:ln>
-          <a:noFill/>
-        </a:ln>
-        <a:effectLst/>
-      </c:spPr>
-    </c:plotArea>
-    <c:plotVisOnly val="1"/>
-    <c:dispBlanksAs val="span"/>
-    <c:showDLblsOverMax val="1"/>
-  </c:chart>
-  <c:spPr>
-    <a:noFill/>
-    <a:ln>
-      <a:noFill/>
-    </a:ln>
-    <a:effectLst/>
-  </c:spPr>
-  <c:externalData r:id="rId1">
-    <c:autoUpdate val="0"/>
-  </c:externalData>
-</c:chartSpace>
-</file>
-
-<file path=ppt/charts/chart2.xml><?xml version="1.0" encoding="utf-8"?>
-<c:chartSpace xmlns:c="http://schemas.openxmlformats.org/drawingml/2006/chart" xmlns:a="http://schemas.openxmlformats.org/drawingml/2006/main" xmlns:r="http://schemas.openxmlformats.org/officeDocument/2006/relationships" xmlns:c16r2="http://schemas.microsoft.com/office/drawing/2015/06/chart">
-  <c:date1904 val="0"/>
-  <c:lang val="en-US"/>
-  <c:roundedCorners val="1"/>
-  <c:style val="2"/>
-  <c:chart>
-    <c:autoTitleDeleted val="1"/>
-    <c:plotArea>
-      <c:layout/>
-      <c:lineChart>
-        <c:grouping val="standard"/>
-        <c:varyColors val="0"/>
-        <c:ser>
-          <c:idx val="0"/>
-          <c:order val="0"/>
-          <c:tx>
-            <c:strRef>
-              <c:f>Sheet1!$B$1</c:f>
-              <c:strCache>
-                <c:ptCount val="1"/>
-                <c:pt idx="0">
-                  <c:v>TAIEX</c:v>
-                </c:pt>
-              </c:strCache>
-            </c:strRef>
-          </c:tx>
-          <c:spPr>
-            <a:ln w="25400" cap="flat">
-              <a:solidFill>
-                <a:srgbClr val="2C5F82"/>
-              </a:solidFill>
-              <a:prstDash val="solid"/>
-              <a:round/>
-            </a:ln>
-            <a:effectLst/>
-          </c:spPr>
-          <c:marker>
-            <c:symbol val="circle"/>
-            <c:size val="3"/>
-            <c:spPr>
-              <a:solidFill>
-                <a:srgbClr val="2C5F82"/>
-              </a:solidFill>
-              <a:ln w="9525" cap="flat">
-                <a:solidFill>
-                  <a:srgbClr val="2C5F82"/>
-                </a:solidFill>
-                <a:prstDash val="solid"/>
-                <a:round/>
-              </a:ln>
-              <a:effectLst/>
-            </c:spPr>
-          </c:marker>
-          <c:cat>
-            <c:strRef>
-              <c:f>Sheet1!$A$2:$A$8</c:f>
-              <c:strCache>
-                <c:ptCount val="7"/>
-                <c:pt idx="0">
-                  <c:v>YE2021</c:v>
-                </c:pt>
-                <c:pt idx="1">
-                  <c:v>YE2022</c:v>
-                </c:pt>
-                <c:pt idx="2">
-                  <c:v>YE2023</c:v>
-                </c:pt>
-                <c:pt idx="3">
-                  <c:v>YE2024</c:v>
-                </c:pt>
-                <c:pt idx="4">
-                  <c:v>YE2025</c:v>
-                </c:pt>
-                <c:pt idx="5">
-                  <c:v>Jun-26 peak</c:v>
-                </c:pt>
-                <c:pt idx="6">
-                  <c:v>Latest</c:v>
-                </c:pt>
-              </c:strCache>
-            </c:strRef>
-          </c:cat>
-          <c:val>
-            <c:numRef>
-              <c:f>Sheet1!$B$2:$B$8</c:f>
-              <c:numCache>
-                <c:formatCode>General</c:formatCode>
-                <c:ptCount val="7"/>
-                <c:pt idx="0">
-                  <c:v>100</c:v>
-                </c:pt>
-                <c:pt idx="1">
-                  <c:v>77.599999999999994</c:v>
-                </c:pt>
-                <c:pt idx="2">
-                  <c:v>98.4</c:v>
-                </c:pt>
-                <c:pt idx="3">
-                  <c:v>126.4</c:v>
-                </c:pt>
-                <c:pt idx="4">
-                  <c:v>159</c:v>
-                </c:pt>
-                <c:pt idx="5">
-                  <c:v>262.10000000000002</c:v>
-                </c:pt>
-                <c:pt idx="6">
-                  <c:v>266.10000000000002</c:v>
-                </c:pt>
-              </c:numCache>
-            </c:numRef>
-          </c:val>
-          <c:smooth val="0"/>
-          <c:extLst>
-            <c:ext xmlns:c16="http://schemas.microsoft.com/office/drawing/2014/chart" uri="{C3380CC4-5D6E-409C-BE32-E72D297353CC}">
-              <c16:uniqueId val="{00000000-AAE1-D940-8B4A-25134FD61442}"/>
-            </c:ext>
-          </c:extLst>
-        </c:ser>
-        <c:ser>
-          <c:idx val="1"/>
-          <c:order val="1"/>
-          <c:tx>
-            <c:strRef>
-              <c:f>Sheet1!$C$1</c:f>
-              <c:strCache>
-                <c:ptCount val="1"/>
-                <c:pt idx="0">
-                  <c:v>KOSPI</c:v>
-                </c:pt>
-              </c:strCache>
-            </c:strRef>
-          </c:tx>
-          <c:spPr>
-            <a:ln w="25400" cap="flat">
-              <a:solidFill>
-                <a:srgbClr val="B23B3B"/>
-              </a:solidFill>
-              <a:prstDash val="solid"/>
-              <a:round/>
-            </a:ln>
-            <a:effectLst/>
-          </c:spPr>
-          <c:marker>
-            <c:symbol val="circle"/>
-            <c:size val="3"/>
-            <c:spPr>
-              <a:solidFill>
-                <a:srgbClr val="B23B3B"/>
-              </a:solidFill>
-              <a:ln w="9525" cap="flat">
-                <a:solidFill>
-                  <a:srgbClr val="B23B3B"/>
-                </a:solidFill>
-                <a:prstDash val="solid"/>
-                <a:round/>
-              </a:ln>
-              <a:effectLst/>
-            </c:spPr>
-          </c:marker>
-          <c:cat>
-            <c:strRef>
-              <c:f>Sheet1!$A$2:$A$8</c:f>
-              <c:strCache>
-                <c:ptCount val="7"/>
-                <c:pt idx="0">
-                  <c:v>YE2021</c:v>
-                </c:pt>
-                <c:pt idx="1">
-                  <c:v>YE2022</c:v>
-                </c:pt>
-                <c:pt idx="2">
-                  <c:v>YE2023</c:v>
-                </c:pt>
-                <c:pt idx="3">
-                  <c:v>YE2024</c:v>
-                </c:pt>
-                <c:pt idx="4">
-                  <c:v>YE2025</c:v>
-                </c:pt>
-                <c:pt idx="5">
-                  <c:v>Jun-26 peak</c:v>
-                </c:pt>
-                <c:pt idx="6">
-                  <c:v>Latest</c:v>
-                </c:pt>
-              </c:strCache>
-            </c:strRef>
-          </c:cat>
-          <c:val>
-            <c:numRef>
-              <c:f>Sheet1!$C$2:$C$8</c:f>
-              <c:numCache>
-                <c:formatCode>General</c:formatCode>
-                <c:ptCount val="7"/>
-                <c:pt idx="0">
-                  <c:v>100</c:v>
-                </c:pt>
-                <c:pt idx="1">
-                  <c:v>75.099999999999994</c:v>
-                </c:pt>
-                <c:pt idx="2">
-                  <c:v>89.2</c:v>
-                </c:pt>
-                <c:pt idx="3">
-                  <c:v>80.599999999999994</c:v>
-                </c:pt>
-                <c:pt idx="4">
-                  <c:v>141.5</c:v>
-                </c:pt>
-                <c:pt idx="5">
-                  <c:v>302.3</c:v>
-                </c:pt>
-                <c:pt idx="6">
-                  <c:v>237.8</c:v>
-                </c:pt>
-              </c:numCache>
-            </c:numRef>
-          </c:val>
-          <c:smooth val="0"/>
-          <c:extLst>
-            <c:ext xmlns:c16="http://schemas.microsoft.com/office/drawing/2014/chart" uri="{C3380CC4-5D6E-409C-BE32-E72D297353CC}">
-              <c16:uniqueId val="{00000001-AAE1-D940-8B4A-25134FD61442}"/>
-            </c:ext>
-          </c:extLst>
-        </c:ser>
-        <c:ser>
-          <c:idx val="2"/>
-          <c:order val="2"/>
-          <c:tx>
-            <c:strRef>
-              <c:f>Sheet1!$D$1</c:f>
-              <c:strCache>
-                <c:ptCount val="1"/>
-                <c:pt idx="0">
-                  <c:v>Nikkei 225</c:v>
-                </c:pt>
-              </c:strCache>
-            </c:strRef>
-          </c:tx>
-          <c:spPr>
-            <a:ln w="25400" cap="flat">
-              <a:solidFill>
-                <a:srgbClr val="A6A6A6"/>
-              </a:solidFill>
-              <a:prstDash val="solid"/>
-              <a:round/>
-            </a:ln>
-            <a:effectLst/>
-          </c:spPr>
-          <c:marker>
-            <c:symbol val="circle"/>
-            <c:size val="3"/>
-            <c:spPr>
-              <a:solidFill>
-                <a:srgbClr val="A6A6A6"/>
-              </a:solidFill>
-              <a:ln w="9525" cap="flat">
-                <a:solidFill>
-                  <a:srgbClr val="A6A6A6"/>
-                </a:solidFill>
-                <a:prstDash val="solid"/>
-                <a:round/>
-              </a:ln>
-              <a:effectLst/>
-            </c:spPr>
-          </c:marker>
-          <c:cat>
-            <c:strRef>
-              <c:f>Sheet1!$A$2:$A$8</c:f>
-              <c:strCache>
-                <c:ptCount val="7"/>
-                <c:pt idx="0">
-                  <c:v>YE2021</c:v>
-                </c:pt>
-                <c:pt idx="1">
-                  <c:v>YE2022</c:v>
-                </c:pt>
-                <c:pt idx="2">
-                  <c:v>YE2023</c:v>
-                </c:pt>
-                <c:pt idx="3">
-                  <c:v>YE2024</c:v>
-                </c:pt>
-                <c:pt idx="4">
-                  <c:v>YE2025</c:v>
-                </c:pt>
-                <c:pt idx="5">
-                  <c:v>Jun-26 peak</c:v>
-                </c:pt>
-                <c:pt idx="6">
-                  <c:v>Latest</c:v>
-                </c:pt>
-              </c:strCache>
-            </c:strRef>
-          </c:cat>
-          <c:val>
-            <c:numRef>
-              <c:f>Sheet1!$D$2:$D$8</c:f>
-              <c:numCache>
-                <c:formatCode>General</c:formatCode>
-                <c:ptCount val="7"/>
-                <c:pt idx="0">
-                  <c:v>100</c:v>
-                </c:pt>
-                <c:pt idx="1">
-                  <c:v>90.6</c:v>
-                </c:pt>
-                <c:pt idx="2">
-                  <c:v>116.2</c:v>
-                </c:pt>
-                <c:pt idx="3">
-                  <c:v>138.6</c:v>
-                </c:pt>
-                <c:pt idx="4">
-                  <c:v>174.8</c:v>
-                </c:pt>
-                <c:pt idx="5">
-                  <c:v>231</c:v>
-                </c:pt>
-                <c:pt idx="6">
-                  <c:v>222.8</c:v>
-                </c:pt>
-              </c:numCache>
-            </c:numRef>
-          </c:val>
-          <c:smooth val="0"/>
-          <c:extLst>
-            <c:ext xmlns:c16="http://schemas.microsoft.com/office/drawing/2014/chart" uri="{C3380CC4-5D6E-409C-BE32-E72D297353CC}">
-              <c16:uniqueId val="{00000002-AAE1-D940-8B4A-25134FD61442}"/>
-            </c:ext>
-          </c:extLst>
-        </c:ser>
-        <c:dLbls>
-          <c:showLegendKey val="0"/>
-          <c:showVal val="0"/>
-          <c:showCatName val="0"/>
-          <c:showSerName val="0"/>
-          <c:showPercent val="0"/>
-          <c:showBubbleSize val="0"/>
-        </c:dLbls>
-        <c:marker val="1"/>
-        <c:smooth val="0"/>
-        <c:axId val="2094734554"/>
-        <c:axId val="2094734552"/>
-      </c:lineChart>
-      <c:catAx>
-        <c:axId val="2094734554"/>
-        <c:scaling>
-          <c:orientation val="minMax"/>
-        </c:scaling>
-        <c:delete val="0"/>
-        <c:axPos val="b"/>
-        <c:numFmt formatCode="General" sourceLinked="1"/>
-        <c:majorTickMark val="out"/>
-        <c:minorTickMark val="none"/>
-        <c:tickLblPos val="low"/>
-        <c:spPr>
-          <a:ln w="12700" cap="flat">
-            <a:solidFill>
-              <a:srgbClr val="BFBFBF"/>
-            </a:solidFill>
-            <a:prstDash val="solid"/>
-            <a:round/>
-          </a:ln>
-        </c:spPr>
-        <c:txPr>
-          <a:bodyPr/>
-          <a:lstStyle/>
-          <a:p>
-            <a:pPr>
-              <a:defRPr sz="650" b="0" i="0" u="none" strike="noStrike">
-                <a:solidFill>
-                  <a:srgbClr val="595959"/>
-                </a:solidFill>
-                <a:latin typeface="Arial"/>
-              </a:defRPr>
-            </a:pPr>
-            <a:endParaRPr lang="en-US"/>
-          </a:p>
-        </c:txPr>
-        <c:crossAx val="2094734552"/>
-        <c:crosses val="autoZero"/>
-        <c:auto val="1"/>
-        <c:lblAlgn val="ctr"/>
-        <c:lblOffset val="100"/>
-        <c:noMultiLvlLbl val="1"/>
-      </c:catAx>
-      <c:valAx>
-        <c:axId val="2094734552"/>
-        <c:scaling>
-          <c:orientation val="minMax"/>
-          <c:max val="325"/>
-          <c:min val="50"/>
-        </c:scaling>
-        <c:delete val="0"/>
-        <c:axPos val="l"/>
-        <c:majorGridlines>
-          <c:spPr>
-            <a:ln w="6350" cap="flat">
-              <a:solidFill>
-                <a:srgbClr val="E3E3E3"/>
-              </a:solidFill>
-              <a:prstDash val="solid"/>
-              <a:round/>
-            </a:ln>
-          </c:spPr>
-        </c:majorGridlines>
-        <c:numFmt formatCode="General" sourceLinked="0"/>
-        <c:majorTickMark val="out"/>
-        <c:minorTickMark val="none"/>
-        <c:tickLblPos val="nextTo"/>
-        <c:spPr>
-          <a:ln w="12700" cap="flat">
-            <a:solidFill>
-              <a:srgbClr val="888888"/>
-            </a:solidFill>
-            <a:prstDash val="solid"/>
-            <a:round/>
-          </a:ln>
-        </c:spPr>
-        <c:txPr>
-          <a:bodyPr/>
-          <a:lstStyle/>
-          <a:p>
-            <a:pPr>
-              <a:defRPr sz="800" b="0" i="0" u="none" strike="noStrike">
-                <a:solidFill>
-                  <a:srgbClr val="595959"/>
-                </a:solidFill>
-                <a:latin typeface="Arial"/>
-              </a:defRPr>
-            </a:pPr>
-            <a:endParaRPr lang="en-US"/>
-          </a:p>
-        </c:txPr>
-        <c:crossAx val="2094734554"/>
-        <c:crosses val="autoZero"/>
-        <c:crossBetween val="between"/>
-        <c:majorUnit val="100"/>
-      </c:valAx>
-      <c:spPr>
-        <a:noFill/>
-        <a:ln>
-          <a:noFill/>
-        </a:ln>
-        <a:effectLst/>
-      </c:spPr>
-    </c:plotArea>
-    <c:legend>
-      <c:legendPos val="r"/>
-      <c:overlay val="0"/>
-      <c:txPr>
-        <a:bodyPr/>
-        <a:lstStyle/>
-        <a:p>
-          <a:pPr>
-            <a:defRPr sz="750">
-              <a:latin typeface="Arial"/>
-              <a:cs typeface="Arial"/>
-            </a:defRPr>
-          </a:pPr>
-          <a:endParaRPr lang="en-US"/>
-        </a:p>
-      </c:txPr>
-    </c:legend>
-    <c:plotVisOnly val="1"/>
-    <c:dispBlanksAs val="span"/>
-    <c:showDLblsOverMax val="1"/>
-  </c:chart>
-  <c:spPr>
-    <a:noFill/>
-    <a:ln>
-      <a:noFill/>
-    </a:ln>
-    <a:effectLst/>
-  </c:spPr>
-  <c:externalData r:id="rId1">
-    <c:autoUpdate val="0"/>
-  </c:externalData>
-</c:chartSpace>
-</file>
-
-<file path=ppt/charts/chart3.xml><?xml version="1.0" encoding="utf-8"?>
-<c:chartSpace xmlns:c="http://schemas.openxmlformats.org/drawingml/2006/chart" xmlns:a="http://schemas.openxmlformats.org/drawingml/2006/main" xmlns:r="http://schemas.openxmlformats.org/officeDocument/2006/relationships" xmlns:c16r2="http://schemas.microsoft.com/office/drawing/2015/06/chart">
-  <c:date1904 val="0"/>
-  <c:lang val="en-US"/>
-  <c:roundedCorners val="1"/>
-  <c:style val="2"/>
-  <c:chart>
-    <c:autoTitleDeleted val="1"/>
-    <c:plotArea>
-      <c:layout/>
-      <c:barChart>
-        <c:barDir val="col"/>
-        <c:grouping val="clustered"/>
-        <c:varyColors val="0"/>
-        <c:ser>
-          <c:idx val="0"/>
-          <c:order val="0"/>
-          <c:tx>
-            <c:strRef>
-              <c:f>Sheet1!$B$1</c:f>
-              <c:strCache>
-                <c:ptCount val="1"/>
-                <c:pt idx="0">
-                  <c:v>5Y USD bond</c:v>
-                </c:pt>
-              </c:strCache>
-            </c:strRef>
-          </c:tx>
-          <c:spPr>
-            <a:solidFill>
-              <a:srgbClr val="404040"/>
-            </a:solidFill>
-            <a:effectLst/>
-          </c:spPr>
-          <c:invertIfNegative val="0"/>
-          <c:dLbls>
-            <c:numFmt formatCode="0.0" sourceLinked="0"/>
-            <c:spPr>
-              <a:noFill/>
-              <a:ln>
-                <a:noFill/>
-              </a:ln>
-              <a:effectLst/>
-            </c:spPr>
-            <c:txPr>
-              <a:bodyPr/>
-              <a:lstStyle/>
-              <a:p>
-                <a:pPr>
-                  <a:defRPr sz="700" b="0" i="0" u="none" strike="noStrike">
-                    <a:solidFill>
-                      <a:srgbClr val="262626"/>
-                    </a:solidFill>
-                    <a:latin typeface="Arial"/>
-                  </a:defRPr>
-                </a:pPr>
-                <a:endParaRPr lang="en-US"/>
-              </a:p>
-            </c:txPr>
-            <c:showLegendKey val="0"/>
-            <c:showVal val="1"/>
-            <c:showCatName val="0"/>
-            <c:showSerName val="0"/>
-            <c:showPercent val="0"/>
-            <c:showBubbleSize val="0"/>
-            <c:showLeaderLines val="0"/>
-            <c:extLst>
-              <c:ext xmlns:c15="http://schemas.microsoft.com/office/drawing/2012/chart" uri="{CE6537A1-D6FC-4f65-9D91-7224C49458BB}">
-                <c15:showLeaderLines val="0"/>
-              </c:ext>
-            </c:extLst>
-          </c:dLbls>
-          <c:cat>
-            <c:strRef>
-              <c:f>Sheet1!$A$2:$A$10</c:f>
-              <c:strCache>
-                <c:ptCount val="9"/>
-                <c:pt idx="0">
-                  <c:v>-2.0%</c:v>
-                </c:pt>
-                <c:pt idx="1">
-                  <c:v>-1.5%</c:v>
-                </c:pt>
-                <c:pt idx="2">
-                  <c:v>-1.0%</c:v>
-                </c:pt>
-                <c:pt idx="3">
-                  <c:v>-0.5%</c:v>
-                </c:pt>
-                <c:pt idx="4">
-                  <c:v>0</c:v>
-                </c:pt>
-                <c:pt idx="5">
-                  <c:v>+0.5%</c:v>
-                </c:pt>
-                <c:pt idx="6">
-                  <c:v>+1.0%</c:v>
-                </c:pt>
-                <c:pt idx="7">
-                  <c:v>+1.5%</c:v>
-                </c:pt>
-                <c:pt idx="8">
-                  <c:v>+2.0%</c:v>
-                </c:pt>
-              </c:strCache>
-            </c:strRef>
-          </c:cat>
-          <c:val>
-            <c:numRef>
-              <c:f>Sheet1!$B$2:$B$10</c:f>
-              <c:numCache>
-                <c:formatCode>General</c:formatCode>
-                <c:ptCount val="9"/>
-                <c:pt idx="0">
-                  <c:v>9.1</c:v>
-                </c:pt>
-                <c:pt idx="1">
-                  <c:v>6.8</c:v>
-                </c:pt>
-                <c:pt idx="2">
-                  <c:v>4.5</c:v>
-                </c:pt>
-                <c:pt idx="3">
-                  <c:v>2.2999999999999998</c:v>
-                </c:pt>
-                <c:pt idx="4">
-                  <c:v>0</c:v>
-                </c:pt>
-                <c:pt idx="5">
-                  <c:v>-2</c:v>
-                </c:pt>
-                <c:pt idx="6">
-                  <c:v>-4</c:v>
-                </c:pt>
-                <c:pt idx="7">
-                  <c:v>-6</c:v>
-                </c:pt>
-                <c:pt idx="8">
-                  <c:v>-7.9</c:v>
-                </c:pt>
-              </c:numCache>
-            </c:numRef>
-          </c:val>
-          <c:extLst>
-            <c:ext xmlns:c16="http://schemas.microsoft.com/office/drawing/2014/chart" uri="{C3380CC4-5D6E-409C-BE32-E72D297353CC}">
-              <c16:uniqueId val="{00000000-CF96-BC4F-A396-002BBEBA77E1}"/>
-            </c:ext>
-          </c:extLst>
-        </c:ser>
-        <c:dLbls>
-          <c:showLegendKey val="0"/>
-          <c:showVal val="1"/>
-          <c:showCatName val="0"/>
-          <c:showSerName val="0"/>
-          <c:showPercent val="0"/>
-          <c:showBubbleSize val="0"/>
-        </c:dLbls>
-        <c:gapWidth val="150"/>
-        <c:axId val="2094734554"/>
-        <c:axId val="2094734552"/>
-      </c:barChart>
-      <c:catAx>
-        <c:axId val="2094734554"/>
-        <c:scaling>
-          <c:orientation val="minMax"/>
-        </c:scaling>
-        <c:delete val="0"/>
-        <c:axPos val="b"/>
-        <c:numFmt formatCode="General" sourceLinked="1"/>
-        <c:majorTickMark val="out"/>
-        <c:minorTickMark val="none"/>
-        <c:tickLblPos val="low"/>
-        <c:spPr>
-          <a:ln w="12700" cap="flat">
-            <a:solidFill>
-              <a:srgbClr val="BFBFBF"/>
-            </a:solidFill>
-            <a:prstDash val="solid"/>
-            <a:round/>
-          </a:ln>
-        </c:spPr>
-        <c:txPr>
-          <a:bodyPr/>
-          <a:lstStyle/>
-          <a:p>
-            <a:pPr>
-              <a:defRPr sz="750" b="0" i="0" u="none" strike="noStrike">
-                <a:solidFill>
-                  <a:srgbClr val="595959"/>
-                </a:solidFill>
-                <a:latin typeface="Arial"/>
-              </a:defRPr>
-            </a:pPr>
-            <a:endParaRPr lang="en-US"/>
-          </a:p>
-        </c:txPr>
-        <c:crossAx val="2094734552"/>
-        <c:crosses val="autoZero"/>
-        <c:auto val="1"/>
-        <c:lblAlgn val="ctr"/>
-        <c:lblOffset val="100"/>
-        <c:noMultiLvlLbl val="1"/>
-      </c:catAx>
-      <c:valAx>
-        <c:axId val="2094734552"/>
-        <c:scaling>
-          <c:orientation val="minMax"/>
-          <c:max val="12"/>
-          <c:min val="-12"/>
-        </c:scaling>
-        <c:delete val="0"/>
-        <c:axPos val="l"/>
-        <c:majorGridlines>
-          <c:spPr>
-            <a:ln w="6350" cap="flat">
-              <a:solidFill>
-                <a:srgbClr val="E3E3E3"/>
-              </a:solidFill>
-              <a:prstDash val="solid"/>
-              <a:round/>
-            </a:ln>
-          </c:spPr>
-        </c:majorGridlines>
-        <c:numFmt formatCode="0&quot;%&quot;" sourceLinked="0"/>
-        <c:majorTickMark val="out"/>
-        <c:minorTickMark val="none"/>
-        <c:tickLblPos val="nextTo"/>
-        <c:spPr>
-          <a:ln w="12700" cap="flat">
-            <a:solidFill>
-              <a:srgbClr val="888888"/>
-            </a:solidFill>
-            <a:prstDash val="solid"/>
-            <a:round/>
-          </a:ln>
-        </c:spPr>
-        <c:txPr>
-          <a:bodyPr/>
-          <a:lstStyle/>
-          <a:p>
-            <a:pPr>
-              <a:defRPr sz="800" b="0" i="0" u="none" strike="noStrike">
-                <a:solidFill>
-                  <a:srgbClr val="595959"/>
-                </a:solidFill>
-                <a:latin typeface="Arial"/>
-              </a:defRPr>
-            </a:pPr>
-            <a:endParaRPr lang="en-US"/>
-          </a:p>
-        </c:txPr>
-        <c:crossAx val="2094734554"/>
-        <c:crosses val="autoZero"/>
-        <c:crossBetween val="between"/>
-        <c:majorUnit val="4"/>
-      </c:valAx>
-      <c:spPr>
-        <a:noFill/>
-        <a:ln>
-          <a:noFill/>
-        </a:ln>
-        <a:effectLst/>
-      </c:spPr>
-    </c:plotArea>
-    <c:plotVisOnly val="1"/>
-    <c:dispBlanksAs val="span"/>
-    <c:showDLblsOverMax val="1"/>
-  </c:chart>
-  <c:spPr>
-    <a:noFill/>
-    <a:ln>
-      <a:noFill/>
-    </a:ln>
-    <a:effectLst/>
-  </c:spPr>
-  <c:externalData r:id="rId1">
-    <c:autoUpdate val="0"/>
-  </c:externalData>
-</c:chartSpace>
-</file>
-
-<file path=ppt/charts/chart4.xml><?xml version="1.0" encoding="utf-8"?>
-<c:chartSpace xmlns:c="http://schemas.openxmlformats.org/drawingml/2006/chart" xmlns:a="http://schemas.openxmlformats.org/drawingml/2006/main" xmlns:r="http://schemas.openxmlformats.org/officeDocument/2006/relationships" xmlns:c16r2="http://schemas.microsoft.com/office/drawing/2015/06/chart">
-  <c:date1904 val="0"/>
-  <c:lang val="en-US"/>
-  <c:roundedCorners val="1"/>
-  <c:style val="2"/>
-  <c:chart>
-    <c:autoTitleDeleted val="1"/>
-    <c:plotArea>
-      <c:layout/>
-      <c:barChart>
-        <c:barDir val="col"/>
-        <c:grouping val="clustered"/>
-        <c:varyColors val="0"/>
-        <c:ser>
-          <c:idx val="0"/>
-          <c:order val="0"/>
-          <c:tx>
-            <c:strRef>
-              <c:f>Sheet1!$B$1</c:f>
-              <c:strCache>
-                <c:ptCount val="1"/>
-                <c:pt idx="0">
-                  <c:v>Trailing P/E</c:v>
-                </c:pt>
-              </c:strCache>
-            </c:strRef>
-          </c:tx>
-          <c:spPr>
-            <a:solidFill>
-              <a:srgbClr val="A6A6A6"/>
-            </a:solidFill>
-            <a:effectLst/>
-          </c:spPr>
-          <c:invertIfNegative val="0"/>
-          <c:dLbls>
-            <c:numFmt formatCode="0.0&quot;×&quot;" sourceLinked="0"/>
-            <c:spPr>
-              <a:noFill/>
-              <a:ln>
-                <a:noFill/>
-              </a:ln>
-              <a:effectLst/>
-            </c:spPr>
-            <c:txPr>
-              <a:bodyPr/>
-              <a:lstStyle/>
-              <a:p>
-                <a:pPr>
-                  <a:defRPr sz="800" b="0" i="0" u="none" strike="noStrike">
-                    <a:solidFill>
-                      <a:srgbClr val="262626"/>
-                    </a:solidFill>
-                    <a:latin typeface="Arial"/>
-                  </a:defRPr>
-                </a:pPr>
-                <a:endParaRPr lang="en-US"/>
-              </a:p>
-            </c:txPr>
-            <c:showLegendKey val="0"/>
-            <c:showVal val="1"/>
-            <c:showCatName val="0"/>
-            <c:showSerName val="0"/>
-            <c:showPercent val="0"/>
-            <c:showBubbleSize val="0"/>
-            <c:showLeaderLines val="0"/>
-            <c:extLst>
-              <c:ext xmlns:c15="http://schemas.microsoft.com/office/drawing/2012/chart" uri="{CE6537A1-D6FC-4f65-9D91-7224C49458BB}">
-                <c15:showLeaderLines val="0"/>
-              </c:ext>
-            </c:extLst>
-          </c:dLbls>
-          <c:cat>
-            <c:strRef>
-              <c:f>Sheet1!$A$2:$A$3</c:f>
-              <c:strCache>
-                <c:ptCount val="2"/>
-                <c:pt idx="0">
-                  <c:v>KOSPI</c:v>
-                </c:pt>
-                <c:pt idx="1">
-                  <c:v>Nikkei 225</c:v>
-                </c:pt>
-              </c:strCache>
-            </c:strRef>
-          </c:cat>
-          <c:val>
-            <c:numRef>
-              <c:f>Sheet1!$B$2:$B$3</c:f>
-              <c:numCache>
-                <c:formatCode>General</c:formatCode>
-                <c:ptCount val="2"/>
-                <c:pt idx="0">
-                  <c:v>22.95</c:v>
-                </c:pt>
-                <c:pt idx="1">
-                  <c:v>22.09</c:v>
-                </c:pt>
-              </c:numCache>
-            </c:numRef>
-          </c:val>
-          <c:extLst>
-            <c:ext xmlns:c16="http://schemas.microsoft.com/office/drawing/2014/chart" uri="{C3380CC4-5D6E-409C-BE32-E72D297353CC}">
-              <c16:uniqueId val="{00000000-1D0C-4044-9AC5-83C28E572E08}"/>
-            </c:ext>
-          </c:extLst>
-        </c:ser>
-        <c:ser>
-          <c:idx val="1"/>
-          <c:order val="1"/>
-          <c:tx>
-            <c:strRef>
-              <c:f>Sheet1!$C$1</c:f>
-              <c:strCache>
-                <c:ptCount val="1"/>
-                <c:pt idx="0">
-                  <c:v>Forward P/E</c:v>
-                </c:pt>
-              </c:strCache>
-            </c:strRef>
-          </c:tx>
-          <c:spPr>
-            <a:solidFill>
-              <a:srgbClr val="2C5F82"/>
-            </a:solidFill>
-            <a:effectLst/>
-          </c:spPr>
-          <c:invertIfNegative val="0"/>
-          <c:dLbls>
-            <c:numFmt formatCode="0.0&quot;×&quot;" sourceLinked="0"/>
-            <c:spPr>
-              <a:noFill/>
-              <a:ln>
-                <a:noFill/>
-              </a:ln>
-              <a:effectLst/>
-            </c:spPr>
-            <c:txPr>
-              <a:bodyPr/>
-              <a:lstStyle/>
-              <a:p>
-                <a:pPr>
-                  <a:defRPr sz="800" b="0" i="0" u="none" strike="noStrike">
-                    <a:solidFill>
-                      <a:srgbClr val="262626"/>
-                    </a:solidFill>
-                    <a:latin typeface="Arial"/>
-                  </a:defRPr>
-                </a:pPr>
-                <a:endParaRPr lang="en-US"/>
-              </a:p>
-            </c:txPr>
-            <c:showLegendKey val="0"/>
-            <c:showVal val="1"/>
-            <c:showCatName val="0"/>
-            <c:showSerName val="0"/>
-            <c:showPercent val="0"/>
-            <c:showBubbleSize val="0"/>
-            <c:showLeaderLines val="0"/>
-            <c:extLst>
-              <c:ext xmlns:c15="http://schemas.microsoft.com/office/drawing/2012/chart" uri="{CE6537A1-D6FC-4f65-9D91-7224C49458BB}">
-                <c15:showLeaderLines val="0"/>
-              </c:ext>
-            </c:extLst>
-          </c:dLbls>
-          <c:cat>
-            <c:strRef>
-              <c:f>Sheet1!$A$2:$A$3</c:f>
-              <c:strCache>
-                <c:ptCount val="2"/>
-                <c:pt idx="0">
-                  <c:v>KOSPI</c:v>
-                </c:pt>
-                <c:pt idx="1">
-                  <c:v>Nikkei 225</c:v>
-                </c:pt>
-              </c:strCache>
-            </c:strRef>
-          </c:cat>
-          <c:val>
-            <c:numRef>
-              <c:f>Sheet1!$C$2:$C$3</c:f>
-              <c:numCache>
-                <c:formatCode>General</c:formatCode>
-                <c:ptCount val="2"/>
-                <c:pt idx="0">
-                  <c:v>7.82</c:v>
-                </c:pt>
-                <c:pt idx="1">
-                  <c:v>17.18</c:v>
-                </c:pt>
-              </c:numCache>
-            </c:numRef>
-          </c:val>
-          <c:extLst>
-            <c:ext xmlns:c16="http://schemas.microsoft.com/office/drawing/2014/chart" uri="{C3380CC4-5D6E-409C-BE32-E72D297353CC}">
-              <c16:uniqueId val="{00000001-1D0C-4044-9AC5-83C28E572E08}"/>
-            </c:ext>
-          </c:extLst>
-        </c:ser>
-        <c:dLbls>
-          <c:showLegendKey val="0"/>
-          <c:showVal val="1"/>
-          <c:showCatName val="0"/>
-          <c:showSerName val="0"/>
-          <c:showPercent val="0"/>
-          <c:showBubbleSize val="0"/>
-        </c:dLbls>
-        <c:gapWidth val="150"/>
-        <c:axId val="2094734554"/>
-        <c:axId val="2094734552"/>
-      </c:barChart>
-      <c:catAx>
-        <c:axId val="2094734554"/>
-        <c:scaling>
-          <c:orientation val="minMax"/>
-        </c:scaling>
-        <c:delete val="0"/>
-        <c:axPos val="b"/>
-        <c:numFmt formatCode="General" sourceLinked="1"/>
-        <c:majorTickMark val="out"/>
-        <c:minorTickMark val="none"/>
-        <c:tickLblPos val="low"/>
-        <c:spPr>
-          <a:ln w="12700" cap="flat">
-            <a:solidFill>
-              <a:srgbClr val="BFBFBF"/>
-            </a:solidFill>
-            <a:prstDash val="solid"/>
-            <a:round/>
-          </a:ln>
-        </c:spPr>
-        <c:txPr>
-          <a:bodyPr/>
-          <a:lstStyle/>
-          <a:p>
-            <a:pPr>
-              <a:defRPr sz="850" b="0" i="0" u="none" strike="noStrike">
-                <a:solidFill>
-                  <a:srgbClr val="595959"/>
-                </a:solidFill>
-                <a:latin typeface="Arial"/>
-              </a:defRPr>
-            </a:pPr>
-            <a:endParaRPr lang="en-US"/>
-          </a:p>
-        </c:txPr>
-        <c:crossAx val="2094734552"/>
-        <c:crosses val="autoZero"/>
-        <c:auto val="1"/>
-        <c:lblAlgn val="ctr"/>
-        <c:lblOffset val="100"/>
-        <c:noMultiLvlLbl val="1"/>
-      </c:catAx>
-      <c:valAx>
-        <c:axId val="2094734552"/>
-        <c:scaling>
-          <c:orientation val="minMax"/>
-          <c:max val="28"/>
-          <c:min val="0"/>
-        </c:scaling>
-        <c:delete val="1"/>
-        <c:axPos val="l"/>
-        <c:numFmt formatCode="General" sourceLinked="0"/>
-        <c:majorTickMark val="out"/>
-        <c:minorTickMark val="none"/>
-        <c:tickLblPos val="nextTo"/>
-        <c:crossAx val="2094734554"/>
-        <c:crosses val="autoZero"/>
-        <c:crossBetween val="between"/>
-      </c:valAx>
-      <c:spPr>
-        <a:noFill/>
-        <a:ln>
-          <a:noFill/>
-        </a:ln>
-        <a:effectLst/>
-      </c:spPr>
-    </c:plotArea>
-    <c:legend>
-      <c:legendPos val="r"/>
-      <c:overlay val="0"/>
-      <c:txPr>
-        <a:bodyPr/>
-        <a:lstStyle/>
-        <a:p>
-          <a:pPr>
-            <a:defRPr sz="800">
-              <a:latin typeface="Arial"/>
-              <a:cs typeface="Arial"/>
-            </a:defRPr>
-          </a:pPr>
-          <a:endParaRPr lang="en-US"/>
-        </a:p>
-      </c:txPr>
-    </c:legend>
-    <c:plotVisOnly val="1"/>
-    <c:dispBlanksAs val="span"/>
-    <c:showDLblsOverMax val="1"/>
-  </c:chart>
-  <c:spPr>
-    <a:noFill/>
-    <a:ln>
-      <a:noFill/>
-    </a:ln>
-    <a:effectLst/>
-  </c:spPr>
-  <c:externalData r:id="rId1">
-    <c:autoUpdate val="0"/>
-  </c:externalData>
-</c:chartSpace>
 </file>
 
 <file path=ppt/charts/chart5.xml><?xml version="1.0" encoding="utf-8"?>
@@ -2126,93 +737,6 @@
 </p:notesMaster>
 </file>
 
-<file path=ppt/notesSlides/notesSlide1.xml><?xml version="1.0" encoding="utf-8"?>
-<p:notes xmlns:a="http://schemas.openxmlformats.org/drawingml/2006/main" xmlns:r="http://schemas.openxmlformats.org/officeDocument/2006/relationships" xmlns:p="http://schemas.openxmlformats.org/presentationml/2006/main">
-  <p:cSld>
-    <p:spTree>
-      <p:nvGrpSpPr>
-        <p:cNvPr id="1" name=""/>
-        <p:cNvGrpSpPr/>
-        <p:nvPr/>
-      </p:nvGrpSpPr>
-      <p:grpSpPr>
-        <a:xfrm>
-          <a:off x="0" y="0"/>
-          <a:ext cx="0" cy="0"/>
-          <a:chOff x="0" y="0"/>
-          <a:chExt cx="0" cy="0"/>
-        </a:xfrm>
-      </p:grpSpPr>
-      <p:sp>
-        <p:nvSpPr>
-          <p:cNvPr id="2" name="Slide Image Placeholder 1"/>
-          <p:cNvSpPr>
-            <a:spLocks noGrp="1" noRot="1" noChangeAspect="1"/>
-          </p:cNvSpPr>
-          <p:nvPr>
-            <p:ph type="sldImg"/>
-          </p:nvPr>
-        </p:nvSpPr>
-        <p:spPr/>
-      </p:sp>
-      <p:sp>
-        <p:nvSpPr>
-          <p:cNvPr id="3" name="Notes Placeholder 2"/>
-          <p:cNvSpPr>
-            <a:spLocks noGrp="1"/>
-          </p:cNvSpPr>
-          <p:nvPr>
-            <p:ph type="body" idx="1"/>
-          </p:nvPr>
-        </p:nvSpPr>
-        <p:spPr/>
-        <p:txBody>
-          <a:bodyPr/>
-          <a:lstStyle/>
-          <a:p>
-            <a:r>
-              <a:rPr lang="en-US" dirty="0"/>
-              <a:t>One-slide thesis 2, modelled on the 'traditional strategies fall short' format, using market evidence only: rising rates (bond duration risk), violent equity paths, concentration, record volatility and a late, richly priced cycle. Implications link each market fact to why an autocallable structure fits; our specific note and its numbers come in the product section.</a:t>
-            </a:r>
-          </a:p>
-        </p:txBody>
-      </p:sp>
-      <p:sp>
-        <p:nvSpPr>
-          <p:cNvPr id="4" name="Slide Number Placeholder 3"/>
-          <p:cNvSpPr>
-            <a:spLocks noGrp="1"/>
-          </p:cNvSpPr>
-          <p:nvPr>
-            <p:ph type="sldNum" sz="quarter" idx="10"/>
-          </p:nvPr>
-        </p:nvSpPr>
-        <p:spPr/>
-        <p:txBody>
-          <a:bodyPr/>
-          <a:lstStyle/>
-          <a:p>
-            <a:fld id="{F7021451-1387-4CA6-816F-3879F97B5CBC}" type="slidenum">
-              <a:rPr lang="en-US"/>
-              <a:t>1</a:t>
-            </a:fld>
-            <a:endParaRPr lang="en-US"/>
-          </a:p>
-        </p:txBody>
-      </p:sp>
-    </p:spTree>
-    <p:extLst>
-      <p:ext uri="{BB962C8B-B14F-4D97-AF65-F5344CB8AC3E}">
-        <p14:creationId xmlns:p14="http://schemas.microsoft.com/office/powerpoint/2010/main" val="1024086991"/>
-      </p:ext>
-    </p:extLst>
-  </p:cSld>
-  <p:clrMapOvr>
-    <a:masterClrMapping/>
-  </p:clrMapOvr>
-</p:notes>
-</file>
-
 <file path=ppt/notesSlides/notesSlide2.xml><?xml version="1.0" encoding="utf-8"?>
 <p:notes xmlns:a="http://schemas.openxmlformats.org/drawingml/2006/main" xmlns:r="http://schemas.openxmlformats.org/officeDocument/2006/relationships" xmlns:p="http://schemas.openxmlformats.org/presentationml/2006/main">
   <p:cSld>
@@ -2718,1645 +1242,6 @@
     </p:otherStyle>
   </p:txStyles>
 </p:sldMaster>
-</file>
-
-<file path=ppt/slides/slide1.xml><?xml version="1.0" encoding="utf-8"?>
-<p:sld xmlns:a="http://schemas.openxmlformats.org/drawingml/2006/main" xmlns:r="http://schemas.openxmlformats.org/officeDocument/2006/relationships" xmlns:p="http://schemas.openxmlformats.org/presentationml/2006/main">
-  <p:cSld>
-    <p:spTree>
-      <p:nvGrpSpPr>
-        <p:cNvPr id="1" name=""/>
-        <p:cNvGrpSpPr/>
-        <p:nvPr/>
-      </p:nvGrpSpPr>
-      <p:grpSpPr>
-        <a:xfrm>
-          <a:off x="0" y="0"/>
-          <a:ext cx="0" cy="0"/>
-          <a:chOff x="0" y="0"/>
-          <a:chExt cx="0" cy="0"/>
-        </a:xfrm>
-      </p:grpSpPr>
-      <p:sp>
-        <p:nvSpPr>
-          <p:cNvPr id="2" name="Text 0"/>
-          <p:cNvSpPr txBox="1"/>
-          <p:nvPr/>
-        </p:nvSpPr>
-        <p:spPr>
-          <a:xfrm>
-            <a:off x="457200" y="274320"/>
-            <a:ext cx="11247120" cy="548640"/>
-          </a:xfrm>
-          <a:prstGeom prst="rect">
-            <a:avLst/>
-          </a:prstGeom>
-          <a:noFill/>
-          <a:ln/>
-        </p:spPr>
-        <p:txBody>
-          <a:bodyPr wrap="square" lIns="0" tIns="0" rIns="0" bIns="0" rtlCol="0" anchor="ctr"/>
-          <a:lstStyle/>
-          <a:p>
-            <a:pPr marL="0" indent="0">
-              <a:buNone/>
-            </a:pPr>
-            <a:r>
-              <a:rPr lang="en-US" sz="2400" dirty="0">
-                <a:solidFill>
-                  <a:srgbClr val="262626"/>
-                </a:solidFill>
-                <a:latin typeface="Arial" pitchFamily="34" charset="0"/>
-                <a:ea typeface="Arial" pitchFamily="34" charset="-122"/>
-                <a:cs typeface="Arial" pitchFamily="34" charset="-120"/>
-              </a:rPr>
-              <a:t>The Macro Regime Shift: Traditional Portfolios Left Exposed</a:t>
-            </a:r>
-            <a:endParaRPr lang="en-US" sz="2400" dirty="0"/>
-          </a:p>
-        </p:txBody>
-      </p:sp>
-      <p:sp>
-        <p:nvSpPr>
-          <p:cNvPr id="3" name="Shape 1"/>
-          <p:cNvSpPr/>
-          <p:nvPr/>
-        </p:nvSpPr>
-        <p:spPr>
-          <a:xfrm>
-            <a:off x="457200" y="896112"/>
-            <a:ext cx="11274552" cy="0"/>
-          </a:xfrm>
-          <a:prstGeom prst="line">
-            <a:avLst/>
-          </a:prstGeom>
-          <a:noFill/>
-          <a:ln w="12700">
-            <a:solidFill>
-              <a:srgbClr val="2C5F82"/>
-            </a:solidFill>
-            <a:prstDash val="solid"/>
-          </a:ln>
-        </p:spPr>
-        <p:txBody>
-          <a:bodyPr/>
-          <a:lstStyle/>
-          <a:p>
-            <a:endParaRPr lang="en-US"/>
-          </a:p>
-        </p:txBody>
-      </p:sp>
-      <p:sp>
-        <p:nvSpPr>
-          <p:cNvPr id="4" name="Shape 2"/>
-          <p:cNvSpPr/>
-          <p:nvPr/>
-        </p:nvSpPr>
-        <p:spPr>
-          <a:xfrm>
-            <a:off x="457200" y="6382512"/>
-            <a:ext cx="11274552" cy="0"/>
-          </a:xfrm>
-          <a:prstGeom prst="line">
-            <a:avLst/>
-          </a:prstGeom>
-          <a:noFill/>
-          <a:ln w="9525">
-            <a:solidFill>
-              <a:srgbClr val="BFBFBF"/>
-            </a:solidFill>
-            <a:prstDash val="solid"/>
-          </a:ln>
-        </p:spPr>
-        <p:txBody>
-          <a:bodyPr/>
-          <a:lstStyle/>
-          <a:p>
-            <a:endParaRPr lang="en-US"/>
-          </a:p>
-        </p:txBody>
-      </p:sp>
-      <p:sp>
-        <p:nvSpPr>
-          <p:cNvPr id="5" name="Shape 3"/>
-          <p:cNvSpPr/>
-          <p:nvPr/>
-        </p:nvSpPr>
-        <p:spPr>
-          <a:xfrm>
-            <a:off x="1005840" y="6364224"/>
-            <a:ext cx="2514600" cy="45720"/>
-          </a:xfrm>
-          <a:prstGeom prst="rect">
-            <a:avLst/>
-          </a:prstGeom>
-          <a:solidFill>
-            <a:srgbClr val="2C5F82"/>
-          </a:solidFill>
-          <a:ln w="12700">
-            <a:solidFill>
-              <a:srgbClr val="2C5F82"/>
-            </a:solidFill>
-            <a:prstDash val="solid"/>
-          </a:ln>
-        </p:spPr>
-        <p:txBody>
-          <a:bodyPr/>
-          <a:lstStyle/>
-          <a:p>
-            <a:endParaRPr lang="en-US"/>
-          </a:p>
-        </p:txBody>
-      </p:sp>
-      <p:sp>
-        <p:nvSpPr>
-          <p:cNvPr id="6" name="Text 4"/>
-          <p:cNvSpPr txBox="1"/>
-          <p:nvPr/>
-        </p:nvSpPr>
-        <p:spPr>
-          <a:xfrm>
-            <a:off x="457200" y="6446520"/>
-            <a:ext cx="3611880" cy="274320"/>
-          </a:xfrm>
-          <a:prstGeom prst="rect">
-            <a:avLst/>
-          </a:prstGeom>
-          <a:noFill/>
-          <a:ln/>
-        </p:spPr>
-        <p:txBody>
-          <a:bodyPr wrap="square" lIns="0" tIns="0" rIns="0" bIns="0" rtlCol="0" anchor="t"/>
-          <a:lstStyle/>
-          <a:p>
-            <a:pPr marL="0" indent="0" algn="ctr">
-              <a:buNone/>
-            </a:pPr>
-            <a:r>
-              <a:rPr lang="en-US" sz="1200" b="1" kern="0" spc="100" dirty="0">
-                <a:solidFill>
-                  <a:srgbClr val="2C5F82"/>
-                </a:solidFill>
-                <a:latin typeface="Arial" pitchFamily="34" charset="0"/>
-                <a:ea typeface="Arial" pitchFamily="34" charset="-122"/>
-                <a:cs typeface="Arial" pitchFamily="34" charset="-120"/>
-              </a:rPr>
-              <a:t>ANALYSIS</a:t>
-            </a:r>
-            <a:endParaRPr lang="en-US" sz="1200" dirty="0"/>
-          </a:p>
-        </p:txBody>
-      </p:sp>
-      <p:sp>
-        <p:nvSpPr>
-          <p:cNvPr id="7" name="Text 5"/>
-          <p:cNvSpPr txBox="1"/>
-          <p:nvPr/>
-        </p:nvSpPr>
-        <p:spPr>
-          <a:xfrm>
-            <a:off x="4288536" y="6446520"/>
-            <a:ext cx="3611880" cy="274320"/>
-          </a:xfrm>
-          <a:prstGeom prst="rect">
-            <a:avLst/>
-          </a:prstGeom>
-          <a:noFill/>
-          <a:ln/>
-        </p:spPr>
-        <p:txBody>
-          <a:bodyPr wrap="square" lIns="0" tIns="0" rIns="0" bIns="0" rtlCol="0" anchor="t"/>
-          <a:lstStyle/>
-          <a:p>
-            <a:pPr marL="0" indent="0" algn="ctr">
-              <a:buNone/>
-            </a:pPr>
-            <a:r>
-              <a:rPr lang="en-US" sz="1200" kern="0" spc="100" dirty="0">
-                <a:solidFill>
-                  <a:srgbClr val="595959"/>
-                </a:solidFill>
-                <a:latin typeface="Arial" pitchFamily="34" charset="0"/>
-                <a:ea typeface="Arial" pitchFamily="34" charset="-122"/>
-                <a:cs typeface="Arial" pitchFamily="34" charset="-120"/>
-              </a:rPr>
-              <a:t>STRATEGY</a:t>
-            </a:r>
-            <a:endParaRPr lang="en-US" sz="1200" dirty="0"/>
-          </a:p>
-        </p:txBody>
-      </p:sp>
-      <p:sp>
-        <p:nvSpPr>
-          <p:cNvPr id="8" name="Text 6"/>
-          <p:cNvSpPr txBox="1"/>
-          <p:nvPr/>
-        </p:nvSpPr>
-        <p:spPr>
-          <a:xfrm>
-            <a:off x="8129016" y="6446520"/>
-            <a:ext cx="3611880" cy="274320"/>
-          </a:xfrm>
-          <a:prstGeom prst="rect">
-            <a:avLst/>
-          </a:prstGeom>
-          <a:noFill/>
-          <a:ln/>
-        </p:spPr>
-        <p:txBody>
-          <a:bodyPr wrap="square" lIns="0" tIns="0" rIns="0" bIns="0" rtlCol="0" anchor="t"/>
-          <a:lstStyle/>
-          <a:p>
-            <a:pPr marL="0" indent="0" algn="ctr">
-              <a:buNone/>
-            </a:pPr>
-            <a:r>
-              <a:rPr lang="en-US" sz="1200" kern="0" spc="100" dirty="0">
-                <a:solidFill>
-                  <a:srgbClr val="595959"/>
-                </a:solidFill>
-                <a:latin typeface="Arial" pitchFamily="34" charset="0"/>
-                <a:ea typeface="Arial" pitchFamily="34" charset="-122"/>
-                <a:cs typeface="Arial" pitchFamily="34" charset="-120"/>
-              </a:rPr>
-              <a:t>APPENDIX</a:t>
-            </a:r>
-            <a:endParaRPr lang="en-US" sz="1200" dirty="0"/>
-          </a:p>
-        </p:txBody>
-      </p:sp>
-      <p:sp>
-        <p:nvSpPr>
-          <p:cNvPr id="9" name="Text 7"/>
-          <p:cNvSpPr txBox="1"/>
-          <p:nvPr/>
-        </p:nvSpPr>
-        <p:spPr>
-          <a:xfrm>
-            <a:off x="457200" y="960120"/>
-            <a:ext cx="11247120" cy="274320"/>
-          </a:xfrm>
-          <a:prstGeom prst="rect">
-            <a:avLst/>
-          </a:prstGeom>
-          <a:noFill/>
-          <a:ln/>
-        </p:spPr>
-        <p:txBody>
-          <a:bodyPr wrap="square" lIns="0" tIns="0" rIns="0" bIns="0" rtlCol="0" anchor="t"/>
-          <a:lstStyle/>
-          <a:p>
-            <a:pPr marL="0" indent="0">
-              <a:buNone/>
-            </a:pPr>
-            <a:r>
-              <a:rPr lang="en-US" sz="1150" b="1" i="1" dirty="0">
-                <a:solidFill>
-                  <a:srgbClr val="262626"/>
-                </a:solidFill>
-                <a:latin typeface="Arial" pitchFamily="34" charset="0"/>
-                <a:ea typeface="Arial" pitchFamily="34" charset="-122"/>
-                <a:cs typeface="Arial" pitchFamily="34" charset="-120"/>
-              </a:rPr>
-              <a:t>Long bonds face rising rates; buy-and-hold equity faces record volatility, concentration and stretched valuations</a:t>
-            </a:r>
-            <a:endParaRPr lang="en-US" sz="1150" dirty="0"/>
-          </a:p>
-        </p:txBody>
-      </p:sp>
-      <p:sp>
-        <p:nvSpPr>
-          <p:cNvPr id="10" name="Shape 8"/>
-          <p:cNvSpPr/>
-          <p:nvPr/>
-        </p:nvSpPr>
-        <p:spPr>
-          <a:xfrm>
-            <a:off x="457200" y="1325880"/>
-            <a:ext cx="3730752" cy="292608"/>
-          </a:xfrm>
-          <a:prstGeom prst="rect">
-            <a:avLst/>
-          </a:prstGeom>
-          <a:solidFill>
-            <a:srgbClr val="2C5F82"/>
-          </a:solidFill>
-          <a:ln w="12700">
-            <a:solidFill>
-              <a:srgbClr val="2C5F82"/>
-            </a:solidFill>
-            <a:prstDash val="solid"/>
-          </a:ln>
-        </p:spPr>
-        <p:txBody>
-          <a:bodyPr/>
-          <a:lstStyle/>
-          <a:p>
-            <a:endParaRPr lang="en-US"/>
-          </a:p>
-        </p:txBody>
-      </p:sp>
-      <p:sp>
-        <p:nvSpPr>
-          <p:cNvPr id="11" name="Text 9"/>
-          <p:cNvSpPr txBox="1"/>
-          <p:nvPr/>
-        </p:nvSpPr>
-        <p:spPr>
-          <a:xfrm>
-            <a:off x="457200" y="1325880"/>
-            <a:ext cx="3730752" cy="292608"/>
-          </a:xfrm>
-          <a:prstGeom prst="rect">
-            <a:avLst/>
-          </a:prstGeom>
-          <a:noFill/>
-          <a:ln/>
-        </p:spPr>
-        <p:txBody>
-          <a:bodyPr wrap="square" lIns="0" tIns="0" rIns="0" bIns="0" rtlCol="0" anchor="ctr"/>
-          <a:lstStyle/>
-          <a:p>
-            <a:pPr marL="0" indent="0" algn="ctr">
-              <a:buNone/>
-            </a:pPr>
-            <a:r>
-              <a:rPr lang="en-US" sz="1050" b="1" dirty="0">
-                <a:solidFill>
-                  <a:srgbClr val="FFFFFF"/>
-                </a:solidFill>
-                <a:latin typeface="Arial" pitchFamily="34" charset="0"/>
-                <a:ea typeface="Arial" pitchFamily="34" charset="-122"/>
-                <a:cs typeface="Arial" pitchFamily="34" charset="-120"/>
-              </a:rPr>
-              <a:t>Rates have been rising again</a:t>
-            </a:r>
-            <a:endParaRPr lang="en-US" sz="1050" dirty="0"/>
-          </a:p>
-        </p:txBody>
-      </p:sp>
-      <p:graphicFrame>
-        <p:nvGraphicFramePr>
-          <p:cNvPr id="12" name="Chart 0"/>
-          <p:cNvGraphicFramePr/>
-          <p:nvPr/>
-        </p:nvGraphicFramePr>
-        <p:xfrm>
-          <a:off x="457200" y="1655064"/>
-          <a:ext cx="3730752" cy="1261872"/>
-        </p:xfrm>
-        <a:graphic>
-          <a:graphicData uri="http://schemas.openxmlformats.org/drawingml/2006/chart">
-            <c:chart xmlns:c="http://schemas.openxmlformats.org/drawingml/2006/chart" xmlns:r="http://schemas.openxmlformats.org/officeDocument/2006/relationships" r:id="rId3"/>
-          </a:graphicData>
-        </a:graphic>
-      </p:graphicFrame>
-      <p:sp>
-        <p:nvSpPr>
-          <p:cNvPr id="13" name="Text 10"/>
-          <p:cNvSpPr txBox="1"/>
-          <p:nvPr/>
-        </p:nvSpPr>
-        <p:spPr>
-          <a:xfrm>
-            <a:off x="457200" y="2953512"/>
-            <a:ext cx="3730752" cy="365760"/>
-          </a:xfrm>
-          <a:prstGeom prst="rect">
-            <a:avLst/>
-          </a:prstGeom>
-          <a:noFill/>
-          <a:ln/>
-        </p:spPr>
-        <p:txBody>
-          <a:bodyPr wrap="square" lIns="0" tIns="0" rIns="0" bIns="0" rtlCol="0" anchor="t"/>
-          <a:lstStyle/>
-          <a:p>
-            <a:pPr marL="0" indent="0">
-              <a:buNone/>
-            </a:pPr>
-            <a:r>
-              <a:rPr lang="en-US" sz="850" dirty="0">
-                <a:solidFill>
-                  <a:srgbClr val="595959"/>
-                </a:solidFill>
-                <a:latin typeface="Arial" pitchFamily="34" charset="0"/>
-                <a:ea typeface="Arial" pitchFamily="34" charset="-122"/>
-                <a:cs typeface="Arial" pitchFamily="34" charset="-120"/>
-              </a:rPr>
-              <a:t>Fed funds upper bound: hikes 2022–23, cuts 2024–25, a hike again on 16 Sep 2026 (median dot 4.1% for end-2026).</a:t>
-            </a:r>
-            <a:endParaRPr lang="en-US" sz="850" dirty="0"/>
-          </a:p>
-        </p:txBody>
-      </p:sp>
-      <p:sp>
-        <p:nvSpPr>
-          <p:cNvPr id="14" name="Shape 11"/>
-          <p:cNvSpPr/>
-          <p:nvPr/>
-        </p:nvSpPr>
-        <p:spPr>
-          <a:xfrm>
-            <a:off x="4370832" y="1325880"/>
-            <a:ext cx="3730752" cy="292608"/>
-          </a:xfrm>
-          <a:prstGeom prst="rect">
-            <a:avLst/>
-          </a:prstGeom>
-          <a:solidFill>
-            <a:srgbClr val="2C5F82"/>
-          </a:solidFill>
-          <a:ln w="12700">
-            <a:solidFill>
-              <a:srgbClr val="2C5F82"/>
-            </a:solidFill>
-            <a:prstDash val="solid"/>
-          </a:ln>
-        </p:spPr>
-        <p:txBody>
-          <a:bodyPr/>
-          <a:lstStyle/>
-          <a:p>
-            <a:endParaRPr lang="en-US"/>
-          </a:p>
-        </p:txBody>
-      </p:sp>
-      <p:sp>
-        <p:nvSpPr>
-          <p:cNvPr id="15" name="Text 12"/>
-          <p:cNvSpPr txBox="1"/>
-          <p:nvPr/>
-        </p:nvSpPr>
-        <p:spPr>
-          <a:xfrm>
-            <a:off x="4370832" y="1325880"/>
-            <a:ext cx="3730752" cy="292608"/>
-          </a:xfrm>
-          <a:prstGeom prst="rect">
-            <a:avLst/>
-          </a:prstGeom>
-          <a:noFill/>
-          <a:ln/>
-        </p:spPr>
-        <p:txBody>
-          <a:bodyPr wrap="square" lIns="0" tIns="0" rIns="0" bIns="0" rtlCol="0" anchor="ctr"/>
-          <a:lstStyle/>
-          <a:p>
-            <a:pPr marL="0" indent="0" algn="ctr">
-              <a:buNone/>
-            </a:pPr>
-            <a:r>
-              <a:rPr lang="en-US" sz="1050" b="1" dirty="0">
-                <a:solidFill>
-                  <a:srgbClr val="FFFFFF"/>
-                </a:solidFill>
-                <a:latin typeface="Arial" pitchFamily="34" charset="0"/>
-                <a:ea typeface="Arial" pitchFamily="34" charset="-122"/>
-                <a:cs typeface="Arial" pitchFamily="34" charset="-120"/>
-              </a:rPr>
-              <a:t>Equity paths are violent</a:t>
-            </a:r>
-            <a:endParaRPr lang="en-US" sz="1050" dirty="0"/>
-          </a:p>
-        </p:txBody>
-      </p:sp>
-      <p:graphicFrame>
-        <p:nvGraphicFramePr>
-          <p:cNvPr id="16" name="Chart 1"/>
-          <p:cNvGraphicFramePr/>
-          <p:nvPr/>
-        </p:nvGraphicFramePr>
-        <p:xfrm>
-          <a:off x="4370832" y="1655064"/>
-          <a:ext cx="3730752" cy="1261872"/>
-        </p:xfrm>
-        <a:graphic>
-          <a:graphicData uri="http://schemas.openxmlformats.org/drawingml/2006/chart">
-            <c:chart xmlns:c="http://schemas.openxmlformats.org/drawingml/2006/chart" xmlns:r="http://schemas.openxmlformats.org/officeDocument/2006/relationships" r:id="rId4"/>
-          </a:graphicData>
-        </a:graphic>
-      </p:graphicFrame>
-      <p:sp>
-        <p:nvSpPr>
-          <p:cNvPr id="17" name="Text 13"/>
-          <p:cNvSpPr txBox="1"/>
-          <p:nvPr/>
-        </p:nvSpPr>
-        <p:spPr>
-          <a:xfrm>
-            <a:off x="4370832" y="2953512"/>
-            <a:ext cx="3730752" cy="365760"/>
-          </a:xfrm>
-          <a:prstGeom prst="rect">
-            <a:avLst/>
-          </a:prstGeom>
-          <a:noFill/>
-          <a:ln/>
-        </p:spPr>
-        <p:txBody>
-          <a:bodyPr wrap="square" lIns="0" tIns="0" rIns="0" bIns="0" rtlCol="0" anchor="t"/>
-          <a:lstStyle/>
-          <a:p>
-            <a:pPr marL="0" indent="0">
-              <a:buNone/>
-            </a:pPr>
-            <a:r>
-              <a:rPr lang="en-US" sz="850" dirty="0">
-                <a:solidFill>
-                  <a:srgbClr val="595959"/>
-                </a:solidFill>
-                <a:latin typeface="Arial" pitchFamily="34" charset="0"/>
-                <a:ea typeface="Arial" pitchFamily="34" charset="-122"/>
-                <a:cs typeface="Arial" pitchFamily="34" charset="-120"/>
-              </a:rPr>
-              <a:t>Index levels, end-2021 = 100: −10–25% in 2022, then 2–3×. KOSPI fell ~25% from June to late August 2026.</a:t>
-            </a:r>
-            <a:endParaRPr lang="en-US" sz="850" dirty="0"/>
-          </a:p>
-        </p:txBody>
-      </p:sp>
-      <p:sp>
-        <p:nvSpPr>
-          <p:cNvPr id="18" name="Shape 14"/>
-          <p:cNvSpPr/>
-          <p:nvPr/>
-        </p:nvSpPr>
-        <p:spPr>
-          <a:xfrm>
-            <a:off x="457200" y="3383280"/>
-            <a:ext cx="3730752" cy="292608"/>
-          </a:xfrm>
-          <a:prstGeom prst="rect">
-            <a:avLst/>
-          </a:prstGeom>
-          <a:solidFill>
-            <a:srgbClr val="2C5F82"/>
-          </a:solidFill>
-          <a:ln w="12700">
-            <a:solidFill>
-              <a:srgbClr val="2C5F82"/>
-            </a:solidFill>
-            <a:prstDash val="solid"/>
-          </a:ln>
-        </p:spPr>
-        <p:txBody>
-          <a:bodyPr/>
-          <a:lstStyle/>
-          <a:p>
-            <a:endParaRPr lang="en-US"/>
-          </a:p>
-        </p:txBody>
-      </p:sp>
-      <p:sp>
-        <p:nvSpPr>
-          <p:cNvPr id="19" name="Text 15"/>
-          <p:cNvSpPr txBox="1"/>
-          <p:nvPr/>
-        </p:nvSpPr>
-        <p:spPr>
-          <a:xfrm>
-            <a:off x="457200" y="3383280"/>
-            <a:ext cx="3730752" cy="292608"/>
-          </a:xfrm>
-          <a:prstGeom prst="rect">
-            <a:avLst/>
-          </a:prstGeom>
-          <a:noFill/>
-          <a:ln/>
-        </p:spPr>
-        <p:txBody>
-          <a:bodyPr wrap="square" lIns="0" tIns="0" rIns="0" bIns="0" rtlCol="0" anchor="ctr"/>
-          <a:lstStyle/>
-          <a:p>
-            <a:pPr marL="0" indent="0" algn="ctr">
-              <a:buNone/>
-            </a:pPr>
-            <a:r>
-              <a:rPr lang="en-US" sz="1050" b="1" dirty="0">
-                <a:solidFill>
-                  <a:srgbClr val="FFFFFF"/>
-                </a:solidFill>
-                <a:latin typeface="Arial" pitchFamily="34" charset="0"/>
-                <a:ea typeface="Arial" pitchFamily="34" charset="-122"/>
-                <a:cs typeface="Arial" pitchFamily="34" charset="-120"/>
-              </a:rPr>
-              <a:t>Long bonds carry rate risk</a:t>
-            </a:r>
-            <a:endParaRPr lang="en-US" sz="1050" dirty="0"/>
-          </a:p>
-        </p:txBody>
-      </p:sp>
-      <p:graphicFrame>
-        <p:nvGraphicFramePr>
-          <p:cNvPr id="20" name="Chart 2"/>
-          <p:cNvGraphicFramePr/>
-          <p:nvPr/>
-        </p:nvGraphicFramePr>
-        <p:xfrm>
-          <a:off x="457200" y="3712464"/>
-          <a:ext cx="3730752" cy="1261872"/>
-        </p:xfrm>
-        <a:graphic>
-          <a:graphicData uri="http://schemas.openxmlformats.org/drawingml/2006/chart">
-            <c:chart xmlns:c="http://schemas.openxmlformats.org/drawingml/2006/chart" xmlns:r="http://schemas.openxmlformats.org/officeDocument/2006/relationships" r:id="rId5"/>
-          </a:graphicData>
-        </a:graphic>
-      </p:graphicFrame>
-      <p:sp>
-        <p:nvSpPr>
-          <p:cNvPr id="21" name="Text 16"/>
-          <p:cNvSpPr txBox="1"/>
-          <p:nvPr/>
-        </p:nvSpPr>
-        <p:spPr>
-          <a:xfrm>
-            <a:off x="457200" y="5010912"/>
-            <a:ext cx="3730752" cy="365760"/>
-          </a:xfrm>
-          <a:prstGeom prst="rect">
-            <a:avLst/>
-          </a:prstGeom>
-          <a:noFill/>
-          <a:ln/>
-        </p:spPr>
-        <p:txBody>
-          <a:bodyPr wrap="square" lIns="0" tIns="0" rIns="0" bIns="0" rtlCol="0" anchor="t"/>
-          <a:lstStyle/>
-          <a:p>
-            <a:pPr marL="0" indent="0">
-              <a:buNone/>
-            </a:pPr>
-            <a:r>
-              <a:rPr lang="en-US" sz="850" dirty="0">
-                <a:solidFill>
-                  <a:srgbClr val="595959"/>
-                </a:solidFill>
-                <a:latin typeface="Arial" pitchFamily="34" charset="0"/>
-                <a:ea typeface="Arial" pitchFamily="34" charset="-122"/>
-                <a:cs typeface="Arial" pitchFamily="34" charset="-120"/>
-              </a:rPr>
-              <a:t>Value change of a 5-year USD bond (5.69% coupon) for parallel rate moves of −2% to +2%.</a:t>
-            </a:r>
-            <a:endParaRPr lang="en-US" sz="850" dirty="0"/>
-          </a:p>
-        </p:txBody>
-      </p:sp>
-      <p:sp>
-        <p:nvSpPr>
-          <p:cNvPr id="22" name="Shape 17"/>
-          <p:cNvSpPr/>
-          <p:nvPr/>
-        </p:nvSpPr>
-        <p:spPr>
-          <a:xfrm>
-            <a:off x="4370832" y="3383280"/>
-            <a:ext cx="3730752" cy="292608"/>
-          </a:xfrm>
-          <a:prstGeom prst="rect">
-            <a:avLst/>
-          </a:prstGeom>
-          <a:solidFill>
-            <a:srgbClr val="2C5F82"/>
-          </a:solidFill>
-          <a:ln w="12700">
-            <a:solidFill>
-              <a:srgbClr val="2C5F82"/>
-            </a:solidFill>
-            <a:prstDash val="solid"/>
-          </a:ln>
-        </p:spPr>
-        <p:txBody>
-          <a:bodyPr/>
-          <a:lstStyle/>
-          <a:p>
-            <a:endParaRPr lang="en-US"/>
-          </a:p>
-        </p:txBody>
-      </p:sp>
-      <p:sp>
-        <p:nvSpPr>
-          <p:cNvPr id="23" name="Text 18"/>
-          <p:cNvSpPr txBox="1"/>
-          <p:nvPr/>
-        </p:nvSpPr>
-        <p:spPr>
-          <a:xfrm>
-            <a:off x="4370832" y="3383280"/>
-            <a:ext cx="3730752" cy="292608"/>
-          </a:xfrm>
-          <a:prstGeom prst="rect">
-            <a:avLst/>
-          </a:prstGeom>
-          <a:noFill/>
-          <a:ln/>
-        </p:spPr>
-        <p:txBody>
-          <a:bodyPr wrap="square" lIns="0" tIns="0" rIns="0" bIns="0" rtlCol="0" anchor="ctr"/>
-          <a:lstStyle/>
-          <a:p>
-            <a:pPr marL="0" indent="0" algn="ctr">
-              <a:buNone/>
-            </a:pPr>
-            <a:r>
-              <a:rPr lang="en-US" sz="1050" b="1" dirty="0">
-                <a:solidFill>
-                  <a:srgbClr val="FFFFFF"/>
-                </a:solidFill>
-                <a:latin typeface="Arial" pitchFamily="34" charset="0"/>
-                <a:ea typeface="Arial" pitchFamily="34" charset="-122"/>
-                <a:cs typeface="Arial" pitchFamily="34" charset="-120"/>
-              </a:rPr>
-              <a:t>Valuations already price in a lot</a:t>
-            </a:r>
-            <a:endParaRPr lang="en-US" sz="1050" dirty="0"/>
-          </a:p>
-        </p:txBody>
-      </p:sp>
-      <p:graphicFrame>
-        <p:nvGraphicFramePr>
-          <p:cNvPr id="24" name="Chart 3"/>
-          <p:cNvGraphicFramePr/>
-          <p:nvPr/>
-        </p:nvGraphicFramePr>
-        <p:xfrm>
-          <a:off x="4370832" y="3712464"/>
-          <a:ext cx="3730752" cy="1261872"/>
-        </p:xfrm>
-        <a:graphic>
-          <a:graphicData uri="http://schemas.openxmlformats.org/drawingml/2006/chart">
-            <c:chart xmlns:c="http://schemas.openxmlformats.org/drawingml/2006/chart" xmlns:r="http://schemas.openxmlformats.org/officeDocument/2006/relationships" r:id="rId6"/>
-          </a:graphicData>
-        </a:graphic>
-      </p:graphicFrame>
-      <p:sp>
-        <p:nvSpPr>
-          <p:cNvPr id="25" name="Text 19"/>
-          <p:cNvSpPr txBox="1"/>
-          <p:nvPr/>
-        </p:nvSpPr>
-        <p:spPr>
-          <a:xfrm>
-            <a:off x="4370832" y="5010912"/>
-            <a:ext cx="3730752" cy="365760"/>
-          </a:xfrm>
-          <a:prstGeom prst="rect">
-            <a:avLst/>
-          </a:prstGeom>
-          <a:noFill/>
-          <a:ln/>
-        </p:spPr>
-        <p:txBody>
-          <a:bodyPr wrap="square" lIns="0" tIns="0" rIns="0" bIns="0" rtlCol="0" anchor="t"/>
-          <a:lstStyle/>
-          <a:p>
-            <a:pPr marL="0" indent="0">
-              <a:buNone/>
-            </a:pPr>
-            <a:r>
-              <a:rPr lang="en-US" sz="850" dirty="0">
-                <a:solidFill>
-                  <a:srgbClr val="595959"/>
-                </a:solidFill>
-                <a:latin typeface="Arial" pitchFamily="34" charset="0"/>
-                <a:ea typeface="Arial" pitchFamily="34" charset="-122"/>
-                <a:cs typeface="Arial" pitchFamily="34" charset="-120"/>
-              </a:rPr>
-              <a:t>Siblis Research, 1 Jul 2026. Korea's gap assumes earnings roughly triple; Nikkei CAPE 38.6×; Taiwan among the most expensive markets.</a:t>
-            </a:r>
-            <a:endParaRPr lang="en-US" sz="850" dirty="0"/>
-          </a:p>
-        </p:txBody>
-      </p:sp>
-      <p:sp>
-        <p:nvSpPr>
-          <p:cNvPr id="26" name="Text 20"/>
-          <p:cNvSpPr txBox="1"/>
-          <p:nvPr/>
-        </p:nvSpPr>
-        <p:spPr>
-          <a:xfrm>
-            <a:off x="8211312" y="1280160"/>
-            <a:ext cx="3520440" cy="320040"/>
-          </a:xfrm>
-          <a:prstGeom prst="rect">
-            <a:avLst/>
-          </a:prstGeom>
-          <a:noFill/>
-          <a:ln/>
-        </p:spPr>
-        <p:txBody>
-          <a:bodyPr wrap="square" lIns="0" tIns="0" rIns="0" bIns="0" rtlCol="0" anchor="t"/>
-          <a:lstStyle/>
-          <a:p>
-            <a:pPr marL="0" indent="0" algn="ctr">
-              <a:buNone/>
-            </a:pPr>
-            <a:r>
-              <a:rPr lang="en-US" sz="1500" b="1" dirty="0">
-                <a:solidFill>
-                  <a:srgbClr val="262626"/>
-                </a:solidFill>
-                <a:latin typeface="Arial" pitchFamily="34" charset="0"/>
-                <a:ea typeface="Arial" pitchFamily="34" charset="-122"/>
-                <a:cs typeface="Arial" pitchFamily="34" charset="-120"/>
-              </a:rPr>
-              <a:t>Implications</a:t>
-            </a:r>
-            <a:endParaRPr lang="en-US" sz="1500" dirty="0"/>
-          </a:p>
-        </p:txBody>
-      </p:sp>
-      <p:sp>
-        <p:nvSpPr>
-          <p:cNvPr id="27" name="Shape 21"/>
-          <p:cNvSpPr/>
-          <p:nvPr/>
-        </p:nvSpPr>
-        <p:spPr>
-          <a:xfrm>
-            <a:off x="8485632" y="1627632"/>
-            <a:ext cx="2971800" cy="0"/>
-          </a:xfrm>
-          <a:prstGeom prst="line">
-            <a:avLst/>
-          </a:prstGeom>
-          <a:noFill/>
-          <a:ln w="9525">
-            <a:solidFill>
-              <a:srgbClr val="2C5F82"/>
-            </a:solidFill>
-            <a:prstDash val="solid"/>
-          </a:ln>
-        </p:spPr>
-        <p:txBody>
-          <a:bodyPr/>
-          <a:lstStyle/>
-          <a:p>
-            <a:endParaRPr lang="en-US"/>
-          </a:p>
-        </p:txBody>
-      </p:sp>
-      <p:sp>
-        <p:nvSpPr>
-          <p:cNvPr id="28" name="Text 22"/>
-          <p:cNvSpPr txBox="1"/>
-          <p:nvPr/>
-        </p:nvSpPr>
-        <p:spPr>
-          <a:xfrm>
-            <a:off x="8211312" y="1645920"/>
-            <a:ext cx="3520440" cy="274320"/>
-          </a:xfrm>
-          <a:prstGeom prst="rect">
-            <a:avLst/>
-          </a:prstGeom>
-          <a:noFill/>
-          <a:ln/>
-        </p:spPr>
-        <p:txBody>
-          <a:bodyPr wrap="square" lIns="0" tIns="0" rIns="0" bIns="0" rtlCol="0" anchor="t"/>
-          <a:lstStyle/>
-          <a:p>
-            <a:pPr marL="0" indent="0" algn="ctr">
-              <a:buNone/>
-            </a:pPr>
-            <a:r>
-              <a:rPr lang="en-US" sz="800" i="1" dirty="0">
-                <a:solidFill>
-                  <a:srgbClr val="595959"/>
-                </a:solidFill>
-                <a:latin typeface="Arial" pitchFamily="34" charset="0"/>
-                <a:ea typeface="Arial" pitchFamily="34" charset="-122"/>
-                <a:cs typeface="Arial" pitchFamily="34" charset="-120"/>
-              </a:rPr>
-              <a:t>Market proof: Taiwan structured-note issuance +81% in 2025, snowball autocalls the favourite payoff (SRP)</a:t>
-            </a:r>
-            <a:endParaRPr lang="en-US" sz="800" dirty="0"/>
-          </a:p>
-        </p:txBody>
-      </p:sp>
-      <p:sp>
-        <p:nvSpPr>
-          <p:cNvPr id="29" name="Shape 23"/>
-          <p:cNvSpPr/>
-          <p:nvPr/>
-        </p:nvSpPr>
-        <p:spPr>
-          <a:xfrm>
-            <a:off x="8211312" y="1938528"/>
-            <a:ext cx="3520440" cy="621792"/>
-          </a:xfrm>
-          <a:prstGeom prst="rect">
-            <a:avLst/>
-          </a:prstGeom>
-          <a:solidFill>
-            <a:srgbClr val="FFFFFF"/>
-          </a:solidFill>
-          <a:ln w="12700">
-            <a:solidFill>
-              <a:srgbClr val="2C5F82"/>
-            </a:solidFill>
-            <a:prstDash val="solid"/>
-          </a:ln>
-        </p:spPr>
-        <p:txBody>
-          <a:bodyPr/>
-          <a:lstStyle/>
-          <a:p>
-            <a:endParaRPr lang="en-US"/>
-          </a:p>
-        </p:txBody>
-      </p:sp>
-      <p:sp>
-        <p:nvSpPr>
-          <p:cNvPr id="30" name="Text 24"/>
-          <p:cNvSpPr txBox="1"/>
-          <p:nvPr/>
-        </p:nvSpPr>
-        <p:spPr>
-          <a:xfrm>
-            <a:off x="8257032" y="1938528"/>
-            <a:ext cx="411480" cy="621792"/>
-          </a:xfrm>
-          <a:prstGeom prst="rect">
-            <a:avLst/>
-          </a:prstGeom>
-          <a:noFill/>
-          <a:ln/>
-        </p:spPr>
-        <p:txBody>
-          <a:bodyPr wrap="square" lIns="0" tIns="0" rIns="0" bIns="0" rtlCol="0" anchor="ctr"/>
-          <a:lstStyle/>
-          <a:p>
-            <a:pPr marL="0" indent="0" algn="ctr">
-              <a:buNone/>
-            </a:pPr>
-            <a:r>
-              <a:rPr lang="en-US" sz="2200" b="1" i="1" dirty="0">
-                <a:solidFill>
-                  <a:srgbClr val="2C5F82"/>
-                </a:solidFill>
-                <a:latin typeface="Arial" pitchFamily="34" charset="0"/>
-                <a:ea typeface="Arial" pitchFamily="34" charset="-122"/>
-                <a:cs typeface="Arial" pitchFamily="34" charset="-120"/>
-              </a:rPr>
-              <a:t>1</a:t>
-            </a:r>
-            <a:endParaRPr lang="en-US" sz="2200" dirty="0"/>
-          </a:p>
-        </p:txBody>
-      </p:sp>
-      <p:sp>
-        <p:nvSpPr>
-          <p:cNvPr id="31" name="Text 25"/>
-          <p:cNvSpPr txBox="1"/>
-          <p:nvPr/>
-        </p:nvSpPr>
-        <p:spPr>
-          <a:xfrm>
-            <a:off x="8714232" y="1956816"/>
-            <a:ext cx="2926080" cy="585216"/>
-          </a:xfrm>
-          <a:prstGeom prst="rect">
-            <a:avLst/>
-          </a:prstGeom>
-          <a:noFill/>
-          <a:ln/>
-        </p:spPr>
-        <p:txBody>
-          <a:bodyPr wrap="square" lIns="0" tIns="0" rIns="0" bIns="0" rtlCol="0" anchor="ctr"/>
-          <a:lstStyle/>
-          <a:p>
-            <a:pPr marL="0" indent="0">
-              <a:buNone/>
-            </a:pPr>
-            <a:r>
-              <a:rPr lang="en-US" sz="880" b="1" dirty="0">
-                <a:solidFill>
-                  <a:srgbClr val="262626"/>
-                </a:solidFill>
-                <a:latin typeface="Arial" pitchFamily="34" charset="0"/>
-                <a:ea typeface="Arial" pitchFamily="34" charset="-122"/>
-                <a:cs typeface="Arial" pitchFamily="34" charset="-120"/>
-              </a:rPr>
-              <a:t>Early exit beats duration: </a:t>
-            </a:r>
-            <a:r>
-              <a:rPr lang="en-US" sz="880" dirty="0">
-                <a:solidFill>
-                  <a:srgbClr val="595959"/>
-                </a:solidFill>
-                <a:latin typeface="Arial" pitchFamily="34" charset="0"/>
-                <a:ea typeface="Arial" pitchFamily="34" charset="-122"/>
-                <a:cs typeface="Arial" pitchFamily="34" charset="-120"/>
-              </a:rPr>
-              <a:t>Bonds lose ~4.0% per 1% rate rise; autocalls can redeem from year 1</a:t>
-            </a:r>
-            <a:endParaRPr lang="en-US" sz="880" dirty="0"/>
-          </a:p>
-        </p:txBody>
-      </p:sp>
-      <p:sp>
-        <p:nvSpPr>
-          <p:cNvPr id="32" name="Shape 26"/>
-          <p:cNvSpPr/>
-          <p:nvPr/>
-        </p:nvSpPr>
-        <p:spPr>
-          <a:xfrm>
-            <a:off x="8211312" y="2633472"/>
-            <a:ext cx="3520440" cy="621792"/>
-          </a:xfrm>
-          <a:prstGeom prst="rect">
-            <a:avLst/>
-          </a:prstGeom>
-          <a:solidFill>
-            <a:srgbClr val="FFFFFF"/>
-          </a:solidFill>
-          <a:ln w="12700">
-            <a:solidFill>
-              <a:srgbClr val="2C5F82"/>
-            </a:solidFill>
-            <a:prstDash val="solid"/>
-          </a:ln>
-        </p:spPr>
-        <p:txBody>
-          <a:bodyPr/>
-          <a:lstStyle/>
-          <a:p>
-            <a:endParaRPr lang="en-US"/>
-          </a:p>
-        </p:txBody>
-      </p:sp>
-      <p:sp>
-        <p:nvSpPr>
-          <p:cNvPr id="33" name="Text 27"/>
-          <p:cNvSpPr txBox="1"/>
-          <p:nvPr/>
-        </p:nvSpPr>
-        <p:spPr>
-          <a:xfrm>
-            <a:off x="8257032" y="2633472"/>
-            <a:ext cx="411480" cy="621792"/>
-          </a:xfrm>
-          <a:prstGeom prst="rect">
-            <a:avLst/>
-          </a:prstGeom>
-          <a:noFill/>
-          <a:ln/>
-        </p:spPr>
-        <p:txBody>
-          <a:bodyPr wrap="square" lIns="0" tIns="0" rIns="0" bIns="0" rtlCol="0" anchor="ctr"/>
-          <a:lstStyle/>
-          <a:p>
-            <a:pPr marL="0" indent="0" algn="ctr">
-              <a:buNone/>
-            </a:pPr>
-            <a:r>
-              <a:rPr lang="en-US" sz="2200" b="1" i="1" dirty="0">
-                <a:solidFill>
-                  <a:srgbClr val="2C5F82"/>
-                </a:solidFill>
-                <a:latin typeface="Arial" pitchFamily="34" charset="0"/>
-                <a:ea typeface="Arial" pitchFamily="34" charset="-122"/>
-                <a:cs typeface="Arial" pitchFamily="34" charset="-120"/>
-              </a:rPr>
-              <a:t>2</a:t>
-            </a:r>
-            <a:endParaRPr lang="en-US" sz="2200" dirty="0"/>
-          </a:p>
-        </p:txBody>
-      </p:sp>
-      <p:sp>
-        <p:nvSpPr>
-          <p:cNvPr id="34" name="Text 28"/>
-          <p:cNvSpPr txBox="1"/>
-          <p:nvPr/>
-        </p:nvSpPr>
-        <p:spPr>
-          <a:xfrm>
-            <a:off x="8714232" y="2651760"/>
-            <a:ext cx="2926080" cy="585216"/>
-          </a:xfrm>
-          <a:prstGeom prst="rect">
-            <a:avLst/>
-          </a:prstGeom>
-          <a:noFill/>
-          <a:ln/>
-        </p:spPr>
-        <p:txBody>
-          <a:bodyPr wrap="square" lIns="0" tIns="0" rIns="0" bIns="0" rtlCol="0" anchor="ctr"/>
-          <a:lstStyle/>
-          <a:p>
-            <a:pPr marL="0" indent="0">
-              <a:buNone/>
-            </a:pPr>
-            <a:r>
-              <a:rPr lang="en-US" sz="880" b="1" dirty="0">
-                <a:solidFill>
-                  <a:srgbClr val="262626"/>
-                </a:solidFill>
-                <a:latin typeface="Arial" pitchFamily="34" charset="0"/>
-                <a:ea typeface="Arial" pitchFamily="34" charset="-122"/>
-                <a:cs typeface="Arial" pitchFamily="34" charset="-120"/>
-              </a:rPr>
-              <a:t>Paid on recovery, not timing: </a:t>
-            </a:r>
-            <a:r>
-              <a:rPr lang="en-US" sz="880" dirty="0">
-                <a:solidFill>
-                  <a:srgbClr val="595959"/>
-                </a:solidFill>
-                <a:latin typeface="Arial" pitchFamily="34" charset="0"/>
-                <a:ea typeface="Arial" pitchFamily="34" charset="-122"/>
-                <a:cs typeface="Arial" pitchFamily="34" charset="-120"/>
-              </a:rPr>
-              <a:t>−25% in ten weeks (KOSPI 2026): autocall coupons pay once the basket is back at its start</a:t>
-            </a:r>
-            <a:endParaRPr lang="en-US" sz="880" dirty="0"/>
-          </a:p>
-        </p:txBody>
-      </p:sp>
-      <p:sp>
-        <p:nvSpPr>
-          <p:cNvPr id="35" name="Shape 29"/>
-          <p:cNvSpPr/>
-          <p:nvPr/>
-        </p:nvSpPr>
-        <p:spPr>
-          <a:xfrm>
-            <a:off x="8211312" y="3328416"/>
-            <a:ext cx="3520440" cy="621792"/>
-          </a:xfrm>
-          <a:prstGeom prst="rect">
-            <a:avLst/>
-          </a:prstGeom>
-          <a:solidFill>
-            <a:srgbClr val="FFFFFF"/>
-          </a:solidFill>
-          <a:ln w="12700">
-            <a:solidFill>
-              <a:srgbClr val="2C5F82"/>
-            </a:solidFill>
-            <a:prstDash val="solid"/>
-          </a:ln>
-        </p:spPr>
-        <p:txBody>
-          <a:bodyPr/>
-          <a:lstStyle/>
-          <a:p>
-            <a:endParaRPr lang="en-US"/>
-          </a:p>
-        </p:txBody>
-      </p:sp>
-      <p:sp>
-        <p:nvSpPr>
-          <p:cNvPr id="36" name="Text 30"/>
-          <p:cNvSpPr txBox="1"/>
-          <p:nvPr/>
-        </p:nvSpPr>
-        <p:spPr>
-          <a:xfrm>
-            <a:off x="8257032" y="3328416"/>
-            <a:ext cx="411480" cy="621792"/>
-          </a:xfrm>
-          <a:prstGeom prst="rect">
-            <a:avLst/>
-          </a:prstGeom>
-          <a:noFill/>
-          <a:ln/>
-        </p:spPr>
-        <p:txBody>
-          <a:bodyPr wrap="square" lIns="0" tIns="0" rIns="0" bIns="0" rtlCol="0" anchor="ctr"/>
-          <a:lstStyle/>
-          <a:p>
-            <a:pPr marL="0" indent="0" algn="ctr">
-              <a:buNone/>
-            </a:pPr>
-            <a:r>
-              <a:rPr lang="en-US" sz="2200" b="1" i="1" dirty="0">
-                <a:solidFill>
-                  <a:srgbClr val="2C5F82"/>
-                </a:solidFill>
-                <a:latin typeface="Arial" pitchFamily="34" charset="0"/>
-                <a:ea typeface="Arial" pitchFamily="34" charset="-122"/>
-                <a:cs typeface="Arial" pitchFamily="34" charset="-120"/>
-              </a:rPr>
-              <a:t>3</a:t>
-            </a:r>
-            <a:endParaRPr lang="en-US" sz="2200" dirty="0"/>
-          </a:p>
-        </p:txBody>
-      </p:sp>
-      <p:sp>
-        <p:nvSpPr>
-          <p:cNvPr id="37" name="Text 31"/>
-          <p:cNvSpPr txBox="1"/>
-          <p:nvPr/>
-        </p:nvSpPr>
-        <p:spPr>
-          <a:xfrm>
-            <a:off x="8714232" y="3346704"/>
-            <a:ext cx="2926080" cy="585216"/>
-          </a:xfrm>
-          <a:prstGeom prst="rect">
-            <a:avLst/>
-          </a:prstGeom>
-          <a:noFill/>
-          <a:ln/>
-        </p:spPr>
-        <p:txBody>
-          <a:bodyPr wrap="square" lIns="0" tIns="0" rIns="0" bIns="0" rtlCol="0" anchor="ctr"/>
-          <a:lstStyle/>
-          <a:p>
-            <a:pPr marL="0" indent="0">
-              <a:buNone/>
-            </a:pPr>
-            <a:r>
-              <a:rPr lang="en-US" sz="880" b="1" dirty="0">
-                <a:solidFill>
-                  <a:srgbClr val="262626"/>
-                </a:solidFill>
-                <a:latin typeface="Arial" pitchFamily="34" charset="0"/>
-                <a:ea typeface="Arial" pitchFamily="34" charset="-122"/>
-                <a:cs typeface="Arial" pitchFamily="34" charset="-120"/>
-              </a:rPr>
-              <a:t>Diversify the basket: </a:t>
-            </a:r>
-            <a:r>
-              <a:rPr lang="en-US" sz="880" dirty="0">
-                <a:solidFill>
-                  <a:srgbClr val="595959"/>
-                </a:solidFill>
-                <a:latin typeface="Arial" pitchFamily="34" charset="0"/>
-                <a:ea typeface="Arial" pitchFamily="34" charset="-122"/>
-                <a:cs typeface="Arial" pitchFamily="34" charset="-120"/>
-              </a:rPr>
-              <a:t>TSMC &gt;40% of TAIEX, ~92% of advanced chips from Taiwan: use a diversified ETF basket, not worst-of</a:t>
-            </a:r>
-            <a:endParaRPr lang="en-US" sz="880" dirty="0"/>
-          </a:p>
-        </p:txBody>
-      </p:sp>
-      <p:sp>
-        <p:nvSpPr>
-          <p:cNvPr id="38" name="Shape 32"/>
-          <p:cNvSpPr/>
-          <p:nvPr/>
-        </p:nvSpPr>
-        <p:spPr>
-          <a:xfrm>
-            <a:off x="8211312" y="4023360"/>
-            <a:ext cx="3520440" cy="621792"/>
-          </a:xfrm>
-          <a:prstGeom prst="rect">
-            <a:avLst/>
-          </a:prstGeom>
-          <a:solidFill>
-            <a:srgbClr val="FFFFFF"/>
-          </a:solidFill>
-          <a:ln w="12700">
-            <a:solidFill>
-              <a:srgbClr val="2C5F82"/>
-            </a:solidFill>
-            <a:prstDash val="solid"/>
-          </a:ln>
-        </p:spPr>
-        <p:txBody>
-          <a:bodyPr/>
-          <a:lstStyle/>
-          <a:p>
-            <a:endParaRPr lang="en-US"/>
-          </a:p>
-        </p:txBody>
-      </p:sp>
-      <p:sp>
-        <p:nvSpPr>
-          <p:cNvPr id="39" name="Text 33"/>
-          <p:cNvSpPr txBox="1"/>
-          <p:nvPr/>
-        </p:nvSpPr>
-        <p:spPr>
-          <a:xfrm>
-            <a:off x="8257032" y="4023360"/>
-            <a:ext cx="411480" cy="621792"/>
-          </a:xfrm>
-          <a:prstGeom prst="rect">
-            <a:avLst/>
-          </a:prstGeom>
-          <a:noFill/>
-          <a:ln/>
-        </p:spPr>
-        <p:txBody>
-          <a:bodyPr wrap="square" lIns="0" tIns="0" rIns="0" bIns="0" rtlCol="0" anchor="ctr"/>
-          <a:lstStyle/>
-          <a:p>
-            <a:pPr marL="0" indent="0" algn="ctr">
-              <a:buNone/>
-            </a:pPr>
-            <a:r>
-              <a:rPr lang="en-US" sz="2200" b="1" i="1" dirty="0">
-                <a:solidFill>
-                  <a:srgbClr val="2C5F82"/>
-                </a:solidFill>
-                <a:latin typeface="Arial" pitchFamily="34" charset="0"/>
-                <a:ea typeface="Arial" pitchFamily="34" charset="-122"/>
-                <a:cs typeface="Arial" pitchFamily="34" charset="-120"/>
-              </a:rPr>
-              <a:t>4</a:t>
-            </a:r>
-            <a:endParaRPr lang="en-US" sz="2200" dirty="0"/>
-          </a:p>
-        </p:txBody>
-      </p:sp>
-      <p:sp>
-        <p:nvSpPr>
-          <p:cNvPr id="40" name="Text 34"/>
-          <p:cNvSpPr txBox="1"/>
-          <p:nvPr/>
-        </p:nvSpPr>
-        <p:spPr>
-          <a:xfrm>
-            <a:off x="8714232" y="4041648"/>
-            <a:ext cx="2926080" cy="585216"/>
-          </a:xfrm>
-          <a:prstGeom prst="rect">
-            <a:avLst/>
-          </a:prstGeom>
-          <a:noFill/>
-          <a:ln/>
-        </p:spPr>
-        <p:txBody>
-          <a:bodyPr wrap="square" lIns="0" tIns="0" rIns="0" bIns="0" rtlCol="0" anchor="ctr"/>
-          <a:lstStyle/>
-          <a:p>
-            <a:pPr marL="0" indent="0">
-              <a:buNone/>
-            </a:pPr>
-            <a:r>
-              <a:rPr lang="en-US" sz="880" b="1" dirty="0">
-                <a:solidFill>
-                  <a:srgbClr val="262626"/>
-                </a:solidFill>
-                <a:latin typeface="Arial" pitchFamily="34" charset="0"/>
-                <a:ea typeface="Arial" pitchFamily="34" charset="-122"/>
-                <a:cs typeface="Arial" pitchFamily="34" charset="-120"/>
-              </a:rPr>
-              <a:t>Volatility funds the coupon: </a:t>
-            </a:r>
-            <a:r>
-              <a:rPr lang="en-US" sz="880" dirty="0">
-                <a:solidFill>
-                  <a:srgbClr val="595959"/>
-                </a:solidFill>
-                <a:latin typeface="Arial" pitchFamily="34" charset="0"/>
-                <a:ea typeface="Arial" pitchFamily="34" charset="-122"/>
-                <a:cs typeface="Arial" pitchFamily="34" charset="-120"/>
-              </a:rPr>
-              <a:t>VKOSPI at a record 91.2: richer option premium means higher autocall coupons</a:t>
-            </a:r>
-            <a:endParaRPr lang="en-US" sz="880" dirty="0"/>
-          </a:p>
-        </p:txBody>
-      </p:sp>
-      <p:sp>
-        <p:nvSpPr>
-          <p:cNvPr id="41" name="Shape 35"/>
-          <p:cNvSpPr/>
-          <p:nvPr/>
-        </p:nvSpPr>
-        <p:spPr>
-          <a:xfrm>
-            <a:off x="8211312" y="4718304"/>
-            <a:ext cx="3520440" cy="621792"/>
-          </a:xfrm>
-          <a:prstGeom prst="rect">
-            <a:avLst/>
-          </a:prstGeom>
-          <a:solidFill>
-            <a:srgbClr val="FFFFFF"/>
-          </a:solidFill>
-          <a:ln w="12700">
-            <a:solidFill>
-              <a:srgbClr val="2C5F82"/>
-            </a:solidFill>
-            <a:prstDash val="solid"/>
-          </a:ln>
-        </p:spPr>
-        <p:txBody>
-          <a:bodyPr/>
-          <a:lstStyle/>
-          <a:p>
-            <a:endParaRPr lang="en-US"/>
-          </a:p>
-        </p:txBody>
-      </p:sp>
-      <p:sp>
-        <p:nvSpPr>
-          <p:cNvPr id="42" name="Text 36"/>
-          <p:cNvSpPr txBox="1"/>
-          <p:nvPr/>
-        </p:nvSpPr>
-        <p:spPr>
-          <a:xfrm>
-            <a:off x="8257032" y="4718304"/>
-            <a:ext cx="411480" cy="621792"/>
-          </a:xfrm>
-          <a:prstGeom prst="rect">
-            <a:avLst/>
-          </a:prstGeom>
-          <a:noFill/>
-          <a:ln/>
-        </p:spPr>
-        <p:txBody>
-          <a:bodyPr wrap="square" lIns="0" tIns="0" rIns="0" bIns="0" rtlCol="0" anchor="ctr"/>
-          <a:lstStyle/>
-          <a:p>
-            <a:pPr marL="0" indent="0" algn="ctr">
-              <a:buNone/>
-            </a:pPr>
-            <a:r>
-              <a:rPr lang="en-US" sz="2200" b="1" i="1" dirty="0">
-                <a:solidFill>
-                  <a:srgbClr val="2C5F82"/>
-                </a:solidFill>
-                <a:latin typeface="Arial" pitchFamily="34" charset="0"/>
-                <a:ea typeface="Arial" pitchFamily="34" charset="-122"/>
-                <a:cs typeface="Arial" pitchFamily="34" charset="-120"/>
-              </a:rPr>
-              <a:t>5</a:t>
-            </a:r>
-            <a:endParaRPr lang="en-US" sz="2200" dirty="0"/>
-          </a:p>
-        </p:txBody>
-      </p:sp>
-      <p:sp>
-        <p:nvSpPr>
-          <p:cNvPr id="43" name="Text 37"/>
-          <p:cNvSpPr txBox="1"/>
-          <p:nvPr/>
-        </p:nvSpPr>
-        <p:spPr>
-          <a:xfrm>
-            <a:off x="8714232" y="4736592"/>
-            <a:ext cx="2926080" cy="585216"/>
-          </a:xfrm>
-          <a:prstGeom prst="rect">
-            <a:avLst/>
-          </a:prstGeom>
-          <a:noFill/>
-          <a:ln/>
-        </p:spPr>
-        <p:txBody>
-          <a:bodyPr wrap="square" lIns="0" tIns="0" rIns="0" bIns="0" rtlCol="0" anchor="ctr"/>
-          <a:lstStyle/>
-          <a:p>
-            <a:pPr marL="0" indent="0">
-              <a:buNone/>
-            </a:pPr>
-            <a:r>
-              <a:rPr lang="en-US" sz="880" b="1" dirty="0">
-                <a:solidFill>
-                  <a:srgbClr val="262626"/>
-                </a:solidFill>
-                <a:latin typeface="Arial" pitchFamily="34" charset="0"/>
-                <a:ea typeface="Arial" pitchFamily="34" charset="-122"/>
-                <a:cs typeface="Arial" pitchFamily="34" charset="-120"/>
-              </a:rPr>
-              <a:t>Protection is affordable: </a:t>
-            </a:r>
-            <a:r>
-              <a:rPr lang="en-US" sz="880" dirty="0">
-                <a:solidFill>
-                  <a:srgbClr val="595959"/>
-                </a:solidFill>
-                <a:latin typeface="Arial" pitchFamily="34" charset="0"/>
-                <a:ea typeface="Arial" pitchFamily="34" charset="-122"/>
-                <a:cs typeface="Arial" pitchFamily="34" charset="-120"/>
-              </a:rPr>
-              <a:t>USD 100 in 5 years costs USD 75.8 at 5.69%: a buffer and a 70% floor fit inside an autocall</a:t>
-            </a:r>
-            <a:endParaRPr lang="en-US" sz="880" dirty="0"/>
-          </a:p>
-        </p:txBody>
-      </p:sp>
-      <p:sp>
-        <p:nvSpPr>
-          <p:cNvPr id="44" name="Shape 38"/>
-          <p:cNvSpPr/>
-          <p:nvPr/>
-        </p:nvSpPr>
-        <p:spPr>
-          <a:xfrm>
-            <a:off x="457200" y="5486400"/>
-            <a:ext cx="11274552" cy="438912"/>
-          </a:xfrm>
-          <a:prstGeom prst="rect">
-            <a:avLst/>
-          </a:prstGeom>
-          <a:solidFill>
-            <a:srgbClr val="2C5F82"/>
-          </a:solidFill>
-          <a:ln w="12700">
-            <a:solidFill>
-              <a:srgbClr val="2C5F82"/>
-            </a:solidFill>
-            <a:prstDash val="solid"/>
-          </a:ln>
-        </p:spPr>
-        <p:txBody>
-          <a:bodyPr/>
-          <a:lstStyle/>
-          <a:p>
-            <a:endParaRPr lang="en-US"/>
-          </a:p>
-        </p:txBody>
-      </p:sp>
-      <p:sp>
-        <p:nvSpPr>
-          <p:cNvPr id="45" name="Text 39"/>
-          <p:cNvSpPr txBox="1"/>
-          <p:nvPr/>
-        </p:nvSpPr>
-        <p:spPr>
-          <a:xfrm>
-            <a:off x="594360" y="5486400"/>
-            <a:ext cx="11000232" cy="438912"/>
-          </a:xfrm>
-          <a:prstGeom prst="rect">
-            <a:avLst/>
-          </a:prstGeom>
-          <a:noFill/>
-          <a:ln/>
-        </p:spPr>
-        <p:txBody>
-          <a:bodyPr wrap="square" lIns="0" tIns="0" rIns="0" bIns="0" rtlCol="0" anchor="ctr"/>
-          <a:lstStyle/>
-          <a:p>
-            <a:pPr marL="0" indent="0" algn="ctr">
-              <a:buNone/>
-            </a:pPr>
-            <a:r>
-              <a:rPr lang="en-US" sz="1200" b="1" dirty="0">
-                <a:solidFill>
-                  <a:srgbClr val="FFFFFF"/>
-                </a:solidFill>
-                <a:latin typeface="Arial" pitchFamily="34" charset="0"/>
-                <a:ea typeface="Arial" pitchFamily="34" charset="-122"/>
-                <a:cs typeface="Arial" pitchFamily="34" charset="-120"/>
-              </a:rPr>
-              <a:t>Plain bonds and equities leave investors exposed; a buffered autocall with a 70% floor keeps the theme and manages the risks.</a:t>
-            </a:r>
-            <a:endParaRPr lang="en-US" sz="1200" dirty="0"/>
-          </a:p>
-        </p:txBody>
-      </p:sp>
-      <p:sp>
-        <p:nvSpPr>
-          <p:cNvPr id="46" name="Text 40"/>
-          <p:cNvSpPr txBox="1"/>
-          <p:nvPr/>
-        </p:nvSpPr>
-        <p:spPr>
-          <a:xfrm>
-            <a:off x="457200" y="5998464"/>
-            <a:ext cx="11274552" cy="274320"/>
-          </a:xfrm>
-          <a:prstGeom prst="rect">
-            <a:avLst/>
-          </a:prstGeom>
-          <a:noFill/>
-          <a:ln/>
-        </p:spPr>
-        <p:txBody>
-          <a:bodyPr wrap="square" lIns="0" tIns="0" rIns="0" bIns="0" rtlCol="0" anchor="t"/>
-          <a:lstStyle/>
-          <a:p>
-            <a:pPr marL="0" indent="0">
-              <a:buNone/>
-            </a:pPr>
-            <a:r>
-              <a:rPr lang="en-US" sz="800" i="1" dirty="0">
-                <a:solidFill>
-                  <a:srgbClr val="595959"/>
-                </a:solidFill>
-                <a:latin typeface="Arial" pitchFamily="34" charset="0"/>
-                <a:ea typeface="Arial" pitchFamily="34" charset="-122"/>
-                <a:cs typeface="Arial" pitchFamily="34" charset="-120"/>
-              </a:rPr>
-              <a:t>Sources: Federal Reserve via Advisor Perspectives; TWSE, KRX/press, Nikkei (index levels); Siblis Research (P/E); Herald / SBS (VKOSPI); TrendForce; J.P. Morgan 2026 Outlook; StructuredRetailProducts.com; case funding grid with standard bond maths.</a:t>
-            </a:r>
-            <a:endParaRPr lang="en-US" sz="800" dirty="0"/>
-          </a:p>
-        </p:txBody>
-      </p:sp>
-    </p:spTree>
-  </p:cSld>
-  <p:clrMapOvr>
-    <a:masterClrMapping/>
-  </p:clrMapOvr>
-</p:sld>
 </file>
 
 <file path=ppt/slides/slide2.xml><?xml version="1.0" encoding="utf-8"?>

</xml_diff>